<commit_message>
Link the three studies everywhere; retire the 14-of-14 feasibility claim; deck updated
- README, evaluation.md ("Beyond accuracy"), FEATURE_STATUS ("Beyond the brief") link
  spc_detection, calibration and business_value with their headline results
- tool_spec, tool_boundaries, chat_tools: the 14-of-14 feasibility claim now points to
  the 180-order test and the widened range
- Deck: slide 2 shows the simulated value (time saved still not measured), slide 6
  risk 3 cites the SPC result, slide 12 the widened range; source map updated

Co-Authored-By: Claude Opus 5.5 <noreply@anthropic.com>
Claude-Session: https://claude.ai/code/session_01L3rS6UNBGMFNb8LKz3WVVc
</commit_message>
<xml_diff>
--- a/threadpilot/docs/presentation/Presentation_GroupNN_Sprint1.pptx
+++ b/threadpilot/docs/presentation/Presentation_GroupNN_Sprint1.pptx
@@ -118,7 +118,7 @@
   <p:extLst>
     <p:ext uri="{521415D9-36F7-43E2-AB2F-B90AF26B5E84}">
       <p14:sectionLst xmlns:p14="http://schemas.microsoft.com/office/powerpoint/2010/main">
-        <p14:section name="Sprint 1" id="{3c3974aa-ef2f-12f6-0ac6-1799cf546990}">
+        <p14:section name="Sprint 1" id="{c46b4016-37ec-0a61-5a2a-682c0c75e0e4}">
           <p14:sldIdLst>
             <p14:sldId id="256"/>
             <p14:sldId id="257"/>
@@ -130,7 +130,7 @@
             <p14:sldId id="263"/>
           </p14:sldIdLst>
         </p14:section>
-        <p14:section name="Backup" id="{58246d25-f3a2-cd99-b2b8-6ecf16ead91e}">
+        <p14:section name="Backup" id="{1f5e19ff-f9e9-7838-db95-414d6fdd55d6}">
           <p14:sldIdLst>
             <p14:sldId id="264"/>
             <p14:sldId id="265"/>
@@ -1251,7 +1251,7 @@
               <a:t>~35 seconds.
 The brief gives five questions a general manager asks across a day. Today each one costs a phone call to a planner and a wait, and the answer is sometimes wrong.
 Our solution is an agent the manager talks to: a morning briefing, a chat that asks when unsure and says what the data cannot answer, and actions only after a confirmation.
-The value, in the brief's words, is the planner's half hour every morning plus every 'let me check and call you back'. We answer all five questions in the demo. We cannot yet show hours saved: no real manager has used it.</a:t>
+The value, in the brief's words, is the planner's half hour every morning plus every 'let me check and call you back'. We answer all five questions in the demo. We cannot yet show hours saved: no real manager has used it. In a paired simulation, finding problems through the briefing avoided about 30 working days of lateness per two months.</a:t>
             </a:r>
             <a:endParaRPr lang="en-US" dirty="0"/>
           </a:p>
@@ -4311,7 +4311,7 @@
                   <a:schemeClr val="tx1"/>
                 </a:solidFill>
               </a:rPr>
-              <a:t>Unlikely by Sat 25 Apr: finishes between Fri 1 May and Fri 8 May. Bottleneck: Packing. An estimate with assumptions, not a commitment.</a:t>
+              <a:t>Unlikely by Sat 25 Apr: between Tue 28 Apr and Tue 12 May. The range is widened by 3 working days each end, because tested on 180 simulated orders the narrower one held the real finish only 7 times in 10 (now 94%).</a:t>
             </a:r>
             <a:endParaRPr lang="en-US" sz="1200" dirty="0"/>
           </a:p>
@@ -5308,12 +5308,12 @@
         </p:nvSpPr>
         <p:spPr>
           <a:xfrm>
-            <a:off x="8354568" y="4846320"/>
-            <a:ext cx="3057144" cy="1005840"/>
+            <a:off x="8354568" y="4617720"/>
+            <a:ext cx="3057144" cy="1325880"/>
           </a:xfrm>
           <a:prstGeom prst="roundRect">
             <a:avLst>
-              <a:gd name="adj" fmla="val 7273"/>
+              <a:gd name="adj" fmla="val 5517"/>
             </a:avLst>
           </a:prstGeom>
           <a:solidFill>
@@ -5330,8 +5330,8 @@
         </p:nvSpPr>
         <p:spPr>
           <a:xfrm>
-            <a:off x="8491728" y="4846320"/>
-            <a:ext cx="2782824" cy="1005840"/>
+            <a:off x="8491728" y="4617720"/>
+            <a:ext cx="2782824" cy="1325880"/>
           </a:xfrm>
           <a:prstGeom prst="rect">
             <a:avLst/>
@@ -5344,10 +5344,13 @@
           <a:lstStyle/>
           <a:p>
             <a:pPr algn="l" indent="0" marL="0">
+              <a:spcAft>
+                <a:spcPts val="400"/>
+              </a:spcAft>
               <a:buNone/>
             </a:pPr>
             <a:r>
-              <a:rPr lang="en-US" sz="1300" b="1" dirty="0">
+              <a:rPr lang="en-US" sz="1200" b="1" dirty="0">
                 <a:solidFill>
                   <a:schemeClr val="accent3"/>
                 </a:solidFill>
@@ -5355,17 +5358,51 @@
               <a:t>Not measured: </a:t>
             </a:r>
             <a:pPr algn="l" indent="0" marL="0">
+              <a:spcAft>
+                <a:spcPts val="400"/>
+              </a:spcAft>
               <a:buNone/>
             </a:pPr>
             <a:r>
-              <a:rPr lang="en-US" sz="1300" dirty="0">
+              <a:rPr lang="en-US" sz="1200" dirty="0">
                 <a:solidFill>
                   <a:schemeClr val="bg1"/>
                 </a:solidFill>
               </a:rPr>
-              <a:t>time saved. No real general manager has used it yet, so we report no hours.</a:t>
-            </a:r>
-            <a:endParaRPr lang="en-US" sz="1300" dirty="0"/>
+              <a:t>time saved; no real manager has used it. </a:t>
+            </a:r>
+            <a:endParaRPr lang="en-US" sz="1200" dirty="0"/>
+          </a:p>
+          <a:p>
+            <a:pPr algn="l" indent="0" marL="0">
+              <a:spcAft>
+                <a:spcPts val="400"/>
+              </a:spcAft>
+              <a:buNone/>
+            </a:pPr>
+            <a:r>
+              <a:rPr lang="en-US" sz="1200" b="1" dirty="0">
+                <a:solidFill>
+                  <a:schemeClr val="accent3"/>
+                </a:solidFill>
+              </a:rPr>
+              <a:t>In simulation: </a:t>
+            </a:r>
+            <a:pPr algn="l" indent="0" marL="0">
+              <a:spcAft>
+                <a:spcPts val="400"/>
+              </a:spcAft>
+              <a:buNone/>
+            </a:pPr>
+            <a:r>
+              <a:rPr lang="en-US" sz="1200" dirty="0">
+                <a:solidFill>
+                  <a:schemeClr val="bg1"/>
+                </a:solidFill>
+              </a:rPr>
+              <a:t>finding problems through the briefing avoided about 30 working days of lateness per two months (95%: 18 to 43).</a:t>
+            </a:r>
+            <a:endParaRPr lang="en-US" sz="1200" dirty="0"/>
           </a:p>
         </p:txBody>
       </p:sp>
@@ -9450,7 +9487,7 @@
                             <a:schemeClr val="tx1"/>
                           </a:solidFill>
                         </a:rPr>
-                        <a:t>One briefing at 07:00. Only watches the manager sets, and a stage under target 3 days running, may interrupt.</a:t>
+                        <a:t>One briefing at 07:00. Stage alerts use 3-sigma + CUSUM: about 2 false alarms a month, against 12 for the old band (measured).</a:t>
                       </a:r>
                       <a:endParaRPr lang="en-US" sz="1250" dirty="0"/>
                     </a:p>

</xml_diff>

<commit_message>
Update the Sprint 1 deck for the morning email and phone fixes
Slide 2 adds the morning email in Outlook; slide 3's action tool and
slide 6's risks 2 and 5 cover who sends it and the per-visitor model
limit; slide 8 says pull request #4 is ready. New backup slide 13: the
email dialog on a phone and a laptop (default Open in Outlook mode),
phone widths, the shared-link guard, and what is not yet tried.
Source table updated. The dialog's "Download .eml" label loses its
double gap.

Co-Authored-By: Claude Opus 5.5 <noreply@anthropic.com>
Claude-Session: https://claude.ai/code/session_01L3rS6UNBGMFNb8LKz3WVVc
</commit_message>
<xml_diff>
--- a/threadpilot/docs/presentation/Presentation_GroupNN_Sprint1.pptx
+++ b/threadpilot/docs/presentation/Presentation_GroupNN_Sprint1.pptx
@@ -17,9 +17,10 @@
     <p:sldId id="265" r:id="rId11"/>
     <p:sldId id="266" r:id="rId12"/>
     <p:sldId id="267" r:id="rId13"/>
+    <p:sldId id="268" r:id="rId14"/>
   </p:sldIdLst>
   <p:notesMasterIdLst>
-    <p:notesMasterId r:id="rId14"/>
+    <p:notesMasterId r:id="rId15"/>
   </p:notesMasterIdLst>
   <p:sldSz cx="12192000" cy="6858000"/>
   <p:notesSz cx="6858000" cy="12192000"/>
@@ -118,7 +119,7 @@
   <p:extLst>
     <p:ext uri="{521415D9-36F7-43E2-AB2F-B90AF26B5E84}">
       <p14:sectionLst xmlns:p14="http://schemas.microsoft.com/office/powerpoint/2010/main">
-        <p14:section name="Sprint 1" id="{c46b4016-37ec-0a61-5a2a-682c0c75e0e4}">
+        <p14:section name="Sprint 1" id="{8f8d30a7-fdb3-a887-4e10-bdba6f5e93d1}">
           <p14:sldIdLst>
             <p14:sldId id="256"/>
             <p14:sldId id="257"/>
@@ -130,12 +131,13 @@
             <p14:sldId id="263"/>
           </p14:sldIdLst>
         </p14:section>
-        <p14:section name="Backup" id="{1f5e19ff-f9e9-7838-db95-414d6fdd55d6}">
+        <p14:section name="Backup" id="{84777e9a-cbf3-4509-0e10-dc55bab767dc}">
           <p14:sldIdLst>
             <p14:sldId id="264"/>
             <p14:sldId id="265"/>
             <p14:sldId id="266"/>
             <p14:sldId id="267"/>
+            <p14:sldId id="268"/>
           </p14:sldIdLst>
         </p14:section>
       </p14:sectionLst>
@@ -1202,6 +1204,97 @@
 </p:notes>
 </file>
 
+<file path=ppt/notesSlides/notesSlide13.xml><?xml version="1.0" encoding="utf-8"?>
+<p:notes xmlns:a="http://schemas.openxmlformats.org/drawingml/2006/main" xmlns:r="http://schemas.openxmlformats.org/officeDocument/2006/relationships" xmlns:p="http://schemas.openxmlformats.org/presentationml/2006/main">
+  <p:cSld>
+    <p:spTree>
+      <p:nvGrpSpPr>
+        <p:cNvPr id="1" name=""/>
+        <p:cNvGrpSpPr/>
+        <p:nvPr/>
+      </p:nvGrpSpPr>
+      <p:grpSpPr>
+        <a:xfrm>
+          <a:off x="0" y="0"/>
+          <a:ext cx="0" cy="0"/>
+          <a:chOff x="0" y="0"/>
+          <a:chExt cx="0" cy="0"/>
+        </a:xfrm>
+      </p:grpSpPr>
+      <p:sp>
+        <p:nvSpPr>
+          <p:cNvPr id="2" name="Slide Image Placeholder 1"/>
+          <p:cNvSpPr>
+            <a:spLocks noGrp="1" noRot="1" noChangeAspect="1"/>
+          </p:cNvSpPr>
+          <p:nvPr>
+            <p:ph type="sldImg"/>
+          </p:nvPr>
+        </p:nvSpPr>
+        <p:spPr/>
+      </p:sp>
+      <p:sp>
+        <p:nvSpPr>
+          <p:cNvPr id="3" name="Notes Placeholder 2"/>
+          <p:cNvSpPr>
+            <a:spLocks noGrp="1"/>
+          </p:cNvSpPr>
+          <p:nvPr>
+            <p:ph type="body" idx="1"/>
+          </p:nvPr>
+        </p:nvSpPr>
+        <p:spPr/>
+        <p:txBody>
+          <a:bodyPr/>
+          <a:lstStyle/>
+          <a:p>
+            <a:r>
+              <a:rPr lang="en-US" dirty="0"/>
+              <a:t>Backup. Use if asked about phones, email or the public link.
+The morning summary becomes an email written from the briefing. The manager reviews it and presses Open in Outlook: Outlook opens with the recipients, subject and text filled in, and they press Send there. Nothing is sent by ThreadPilot itself. One-click sending from inside ThreadPilot is built and tested, but it needs a one-time Microsoft app registration, so it is off until someone does that.
+Phones: a new test checks every page at phone widths; it found that hidden screen-reader labels made the briefing page 878 px wide on a 390 px phone. Fixed.
+Shared link: a per-visitor limit protects the OpenAI credit; a wrong key gives a clear message instead of a generic error.</a:t>
+            </a:r>
+            <a:endParaRPr lang="en-US" dirty="0"/>
+          </a:p>
+        </p:txBody>
+      </p:sp>
+      <p:sp>
+        <p:nvSpPr>
+          <p:cNvPr id="4" name="Slide Number Placeholder 3"/>
+          <p:cNvSpPr>
+            <a:spLocks noGrp="1"/>
+          </p:cNvSpPr>
+          <p:nvPr>
+            <p:ph type="sldNum" sz="quarter" idx="10"/>
+          </p:nvPr>
+        </p:nvSpPr>
+        <p:spPr/>
+        <p:txBody>
+          <a:bodyPr/>
+          <a:lstStyle/>
+          <a:p>
+            <a:fld id="{F7021451-1387-4CA6-816F-3879F97B5CBC}" type="slidenum">
+              <a:rPr lang="en-US"/>
+              <a:t>13</a:t>
+            </a:fld>
+            <a:endParaRPr lang="en-US"/>
+          </a:p>
+        </p:txBody>
+      </p:sp>
+    </p:spTree>
+    <p:extLst>
+      <p:ext uri="{BB962C8B-B14F-4D97-AF65-F5344CB8AC3E}">
+        <p14:creationId xmlns:p14="http://schemas.microsoft.com/office/powerpoint/2010/main" val="1024086991"/>
+      </p:ext>
+    </p:extLst>
+  </p:cSld>
+  <p:clrMapOvr>
+    <a:masterClrMapping/>
+  </p:clrMapOvr>
+</p:notes>
+</file>
+
 <file path=ppt/notesSlides/notesSlide2.xml><?xml version="1.0" encoding="utf-8"?>
 <p:notes xmlns:a="http://schemas.openxmlformats.org/drawingml/2006/main" xmlns:r="http://schemas.openxmlformats.org/officeDocument/2006/relationships" xmlns:p="http://schemas.openxmlformats.org/presentationml/2006/main">
   <p:cSld>
@@ -1250,7 +1343,7 @@
               <a:rPr lang="en-US" dirty="0"/>
               <a:t>~35 seconds.
 The brief gives five questions a general manager asks across a day. Today each one costs a phone call to a planner and a wait, and the answer is sometimes wrong.
-Our solution is an agent the manager talks to: a morning briefing, a chat that asks when unsure and says what the data cannot answer, and actions only after a confirmation.
+Our solution is an agent the manager talks to: a morning briefing, a chat that asks when unsure and says what the data cannot answer, and actions only after a confirmation. The morning summary goes out as an email from the manager's own Outlook.
 The value, in the brief's words, is the planner's half hour every morning plus every 'let me check and call you back'. We answer all five questions in the demo. We cannot yet show hours saved: no real manager has used it. In a paired simulation, finding problems through the briefing avoided about 30 working days of lateness per two months.</a:t>
             </a:r>
             <a:endParaRPr lang="en-US" dirty="0"/>
@@ -1795,7 +1888,7 @@
             <a:r>
               <a:rPr lang="en-US" dirty="0"/>
               <a:t>~35 seconds.
-Sprint 2 is about proving it, not adding features. First, run the live backend once on the 36 questions and report it as first pass. Second, each teammate adds ten blind questions. Third, put the briefing on the team's cloud site. Fourth, settle on one feasibility method.
+Sprint 2 is about proving it, not adding features. First, run the live backend once on the 36 questions and report it as first pass. Second, each teammate adds ten blind questions. Third, put the briefing on the team's cloud site: the pull request is ready and passes every test once merged. Fourth, settle on one feasibility method.
 Success criteria: the live result reported as it ran, at least 70 percent on blind questions against 67 on our own, no number without a source row, public links that open, and an owner for every feature.
 [Team: the success criteria and the 70 percent target are a proposal drawn from the repository's own results. Agree them and add an owner to each roadmap row before presenting.]</a:t>
             </a:r>
@@ -4406,6 +4499,608 @@
 </p:sld>
 </file>
 
+<file path=ppt/slides/slide13.xml><?xml version="1.0" encoding="utf-8"?>
+<p:sld xmlns:a="http://schemas.openxmlformats.org/drawingml/2006/main" xmlns:r="http://schemas.openxmlformats.org/officeDocument/2006/relationships" xmlns:p="http://schemas.openxmlformats.org/presentationml/2006/main">
+  <p:cSld name="Slide 13">
+    <p:spTree>
+      <p:nvGrpSpPr>
+        <p:cNvPr id="1" name=""/>
+        <p:cNvGrpSpPr/>
+        <p:nvPr/>
+      </p:nvGrpSpPr>
+      <p:grpSpPr>
+        <a:xfrm>
+          <a:off x="0" y="0"/>
+          <a:ext cx="0" cy="0"/>
+          <a:chOff x="0" y="0"/>
+          <a:chExt cx="0" cy="0"/>
+        </a:xfrm>
+      </p:grpSpPr>
+      <p:sp>
+        <p:nvSpPr>
+          <p:cNvPr id="2" name="Text 0"/>
+          <p:cNvSpPr/>
+          <p:nvPr>
+            <p:ph idx="100" type="title" hasCustomPrompt="1"/>
+          </p:nvPr>
+        </p:nvSpPr>
+        <p:spPr>
+          <a:xfrm>
+            <a:off x="548640" y="320040"/>
+            <a:ext cx="11091672" cy="822960"/>
+          </a:xfrm>
+          <a:prstGeom prst="rect">
+            <a:avLst/>
+          </a:prstGeom>
+          <a:noFill/>
+          <a:ln/>
+        </p:spPr>
+        <p:txBody>
+          <a:bodyPr wrap="square" lIns="0" tIns="0" rIns="0" bIns="0" rtlCol="0" anchor="ctr"/>
+          <a:lstStyle/>
+          <a:p>
+            <a:pPr algn="l" indent="0" marL="0">
+              <a:buNone/>
+            </a:pPr>
+            <a:r>
+              <a:rPr lang="en-US" sz="3200" b="1" dirty="0">
+                <a:solidFill>
+                  <a:schemeClr val="tx2"/>
+                </a:solidFill>
+              </a:rPr>
+              <a:t>Backup: ready for a phone and a shared link</a:t>
+            </a:r>
+            <a:endParaRPr lang="en-US" sz="3200" dirty="0"/>
+          </a:p>
+        </p:txBody>
+      </p:sp>
+      <p:sp>
+        <p:nvSpPr>
+          <p:cNvPr id="3" name="Backup tag"/>
+          <p:cNvSpPr txBox="1"/>
+          <p:nvPr/>
+        </p:nvSpPr>
+        <p:spPr>
+          <a:xfrm>
+            <a:off x="10515600" y="566928"/>
+            <a:ext cx="1124712" cy="292608"/>
+          </a:xfrm>
+          <a:prstGeom prst="roundRect">
+            <a:avLst>
+              <a:gd name="adj" fmla="val 31250"/>
+            </a:avLst>
+          </a:prstGeom>
+          <a:solidFill>
+            <a:schemeClr val="accent5"/>
+          </a:solidFill>
+          <a:ln/>
+        </p:spPr>
+        <p:txBody>
+          <a:bodyPr wrap="square" lIns="0" tIns="0" rIns="0" bIns="0" rtlCol="0" anchor="ctr"/>
+          <a:lstStyle/>
+          <a:p>
+            <a:pPr algn="ctr" indent="0" marL="0">
+              <a:buNone/>
+            </a:pPr>
+            <a:r>
+              <a:rPr lang="en-US" sz="1100" b="1" dirty="0">
+                <a:solidFill>
+                  <a:schemeClr val="bg1"/>
+                </a:solidFill>
+              </a:rPr>
+              <a:t>BACKUP</a:t>
+            </a:r>
+            <a:endParaRPr lang="en-US" sz="1100" dirty="0"/>
+          </a:p>
+        </p:txBody>
+      </p:sp>
+      <p:sp>
+        <p:nvSpPr>
+          <p:cNvPr id="4" name="Label"/>
+          <p:cNvSpPr txBox="1"/>
+          <p:nvPr/>
+        </p:nvSpPr>
+        <p:spPr>
+          <a:xfrm>
+            <a:off x="548640" y="1280160"/>
+            <a:ext cx="2377440" cy="411480"/>
+          </a:xfrm>
+          <a:prstGeom prst="rect">
+            <a:avLst/>
+          </a:prstGeom>
+          <a:noFill/>
+          <a:ln/>
+        </p:spPr>
+        <p:txBody>
+          <a:bodyPr wrap="square" lIns="0" tIns="0" rIns="0" bIns="0" rtlCol="0" anchor="ctr"/>
+          <a:lstStyle/>
+          <a:p>
+            <a:pPr algn="l" indent="0" marL="0">
+              <a:buNone/>
+            </a:pPr>
+            <a:r>
+              <a:rPr lang="en-US" sz="1600" b="1" dirty="0">
+                <a:solidFill>
+                  <a:schemeClr val="tx2"/>
+                </a:solidFill>
+              </a:rPr>
+              <a:t>On a phone</a:t>
+            </a:r>
+            <a:endParaRPr lang="en-US" sz="1600" dirty="0"/>
+          </a:p>
+        </p:txBody>
+      </p:sp>
+      <p:sp>
+        <p:nvSpPr>
+          <p:cNvPr id="5" name="Phone email screenshot frame"/>
+          <p:cNvSpPr/>
+          <p:nvPr/>
+        </p:nvSpPr>
+        <p:spPr>
+          <a:xfrm>
+            <a:off x="502920" y="1737360"/>
+            <a:ext cx="1997483" cy="4160520"/>
+          </a:xfrm>
+          <a:prstGeom prst="roundRect">
+            <a:avLst>
+              <a:gd name="adj" fmla="val 2747"/>
+            </a:avLst>
+          </a:prstGeom>
+          <a:solidFill>
+            <a:schemeClr val="bg1"/>
+          </a:solidFill>
+          <a:ln w="12700">
+            <a:solidFill>
+              <a:schemeClr val="bg2"/>
+            </a:solidFill>
+            <a:prstDash val="solid"/>
+          </a:ln>
+          <a:effectLst>
+            <a:outerShdw sx="100000" sy="100000" kx="0" ky="0" algn="bl" rotWithShape="0" blurRad="101600" dist="25400" dir="5400000">
+              <a:srgbClr val="000000">
+                <a:alpha val="16000"/>
+              </a:srgbClr>
+            </a:outerShdw>
+          </a:effectLst>
+        </p:spPr>
+      </p:sp>
+      <p:pic>
+        <p:nvPicPr>
+          <p:cNvPr id="6" name="Phone email screenshot" descr="The morning summary email on a 390-pixel phone: To, Cc, subject and message filled in, with a full-width Open in Outlook button">    </p:cNvPr>
+          <p:cNvPicPr>
+            <a:picLocks noChangeAspect="1"/>
+          </p:cNvPicPr>
+          <p:nvPr/>
+        </p:nvPicPr>
+        <p:blipFill>
+          <a:blip r:embed="rId1"/>
+          <a:stretch>
+            <a:fillRect/>
+          </a:stretch>
+        </p:blipFill>
+        <p:spPr>
+          <a:xfrm>
+            <a:off x="548640" y="1783080"/>
+            <a:ext cx="1906043" cy="4069080"/>
+          </a:xfrm>
+          <a:prstGeom prst="rect">
+            <a:avLst/>
+          </a:prstGeom>
+        </p:spPr>
+      </p:pic>
+      <p:sp>
+        <p:nvSpPr>
+          <p:cNvPr id="7" name="Label"/>
+          <p:cNvSpPr txBox="1"/>
+          <p:nvPr/>
+        </p:nvSpPr>
+        <p:spPr>
+          <a:xfrm>
+            <a:off x="2820443" y="1280160"/>
+            <a:ext cx="3291840" cy="411480"/>
+          </a:xfrm>
+          <a:prstGeom prst="rect">
+            <a:avLst/>
+          </a:prstGeom>
+          <a:noFill/>
+          <a:ln/>
+        </p:spPr>
+        <p:txBody>
+          <a:bodyPr wrap="square" lIns="0" tIns="0" rIns="0" bIns="0" rtlCol="0" anchor="ctr"/>
+          <a:lstStyle/>
+          <a:p>
+            <a:pPr algn="l" indent="0" marL="0">
+              <a:buNone/>
+            </a:pPr>
+            <a:r>
+              <a:rPr lang="en-US" sz="1600" b="1" dirty="0">
+                <a:solidFill>
+                  <a:schemeClr val="tx2"/>
+                </a:solidFill>
+              </a:rPr>
+              <a:t>On a laptop</a:t>
+            </a:r>
+            <a:endParaRPr lang="en-US" sz="1600" dirty="0"/>
+          </a:p>
+        </p:txBody>
+      </p:sp>
+      <p:sp>
+        <p:nvSpPr>
+          <p:cNvPr id="8" name="Desktop email screenshot frame"/>
+          <p:cNvSpPr/>
+          <p:nvPr/>
+        </p:nvSpPr>
+        <p:spPr>
+          <a:xfrm>
+            <a:off x="2774723" y="1737360"/>
+            <a:ext cx="3708400" cy="4160520"/>
+          </a:xfrm>
+          <a:prstGeom prst="roundRect">
+            <a:avLst>
+              <a:gd name="adj" fmla="val 1479"/>
+            </a:avLst>
+          </a:prstGeom>
+          <a:solidFill>
+            <a:schemeClr val="bg1"/>
+          </a:solidFill>
+          <a:ln w="12700">
+            <a:solidFill>
+              <a:schemeClr val="bg2"/>
+            </a:solidFill>
+            <a:prstDash val="solid"/>
+          </a:ln>
+          <a:effectLst>
+            <a:outerShdw sx="100000" sy="100000" kx="0" ky="0" algn="bl" rotWithShape="0" blurRad="101600" dist="25400" dir="5400000">
+              <a:srgbClr val="000000">
+                <a:alpha val="16000"/>
+              </a:srgbClr>
+            </a:outerShdw>
+          </a:effectLst>
+        </p:spPr>
+      </p:sp>
+      <p:pic>
+        <p:nvPicPr>
+          <p:cNvPr id="9" name="Desktop email screenshot" descr="The morning summary email dialog on a laptop, with recipients filled in and an Open in Outlook button">    </p:cNvPr>
+          <p:cNvPicPr>
+            <a:picLocks noChangeAspect="1"/>
+          </p:cNvPicPr>
+          <p:nvPr/>
+        </p:nvPicPr>
+        <p:blipFill>
+          <a:blip r:embed="rId2"/>
+          <a:stretch>
+            <a:fillRect/>
+          </a:stretch>
+        </p:blipFill>
+        <p:spPr>
+          <a:xfrm>
+            <a:off x="2820443" y="1783080"/>
+            <a:ext cx="3616960" cy="4069080"/>
+          </a:xfrm>
+          <a:prstGeom prst="rect">
+            <a:avLst/>
+          </a:prstGeom>
+        </p:spPr>
+      </p:pic>
+      <p:sp>
+        <p:nvSpPr>
+          <p:cNvPr id="10" name="Readiness points"/>
+          <p:cNvSpPr txBox="1"/>
+          <p:nvPr/>
+        </p:nvSpPr>
+        <p:spPr>
+          <a:xfrm>
+            <a:off x="6848883" y="1325880"/>
+            <a:ext cx="4791429" cy="3566160"/>
+          </a:xfrm>
+          <a:prstGeom prst="rect">
+            <a:avLst/>
+          </a:prstGeom>
+          <a:noFill/>
+          <a:ln/>
+        </p:spPr>
+        <p:txBody>
+          <a:bodyPr wrap="square" lIns="0" tIns="0" rIns="0" bIns="0" rtlCol="0" anchor="t"/>
+          <a:lstStyle/>
+          <a:p>
+            <a:pPr algn="l" indent="0" marL="0">
+              <a:spcAft>
+                <a:spcPts val="900"/>
+              </a:spcAft>
+              <a:buNone/>
+            </a:pPr>
+            <a:r>
+              <a:rPr lang="en-US" sz="1500" b="1" dirty="0">
+                <a:solidFill>
+                  <a:schemeClr val="tx2"/>
+                </a:solidFill>
+              </a:rPr>
+              <a:t>Morning email</a:t>
+            </a:r>
+            <a:endParaRPr lang="en-US" sz="1500" dirty="0"/>
+          </a:p>
+          <a:p>
+            <a:pPr algn="l" indent="0" marL="0">
+              <a:spcAft>
+                <a:spcPts val="900"/>
+              </a:spcAft>
+              <a:buNone/>
+            </a:pPr>
+            <a:r>
+              <a:rPr lang="en-US" sz="1250" dirty="0">
+                <a:solidFill>
+                  <a:schemeClr val="tx1"/>
+                </a:solidFill>
+              </a:rPr>
+              <a:t>Written from the 07:00 briefing; recipients carried over from the last one. Open in Outlook: a filled-in Outlook window, the manager presses Send. One-click sending needs a one-time Microsoft app registration (send-only permission).</a:t>
+            </a:r>
+            <a:endParaRPr lang="en-US" sz="1500" dirty="0"/>
+          </a:p>
+          <a:p>
+            <a:pPr algn="l" indent="0" marL="0">
+              <a:spcAft>
+                <a:spcPts val="900"/>
+              </a:spcAft>
+              <a:buNone/>
+            </a:pPr>
+            <a:r>
+              <a:rPr lang="en-US" sz="1500" b="1" dirty="0">
+                <a:solidFill>
+                  <a:schemeClr val="tx2"/>
+                </a:solidFill>
+              </a:rPr>
+              <a:t>Phones</a:t>
+            </a:r>
+            <a:endParaRPr lang="en-US" sz="1500" dirty="0"/>
+          </a:p>
+          <a:p>
+            <a:pPr algn="l" indent="0" marL="0">
+              <a:spcAft>
+                <a:spcPts val="900"/>
+              </a:spcAft>
+              <a:buNone/>
+            </a:pPr>
+            <a:r>
+              <a:rPr lang="en-US" sz="1250" dirty="0">
+                <a:solidFill>
+                  <a:schemeClr val="tx1"/>
+                </a:solidFill>
+              </a:rPr>
+              <a:t>No page scrolls sideways from 320 to 390 px. The briefing page was 878 px wide on a 390 px phone; a new test found it, and it is fixed.</a:t>
+            </a:r>
+            <a:endParaRPr lang="en-US" sz="1500" dirty="0"/>
+          </a:p>
+          <a:p>
+            <a:pPr algn="l" indent="0" marL="0">
+              <a:spcAft>
+                <a:spcPts val="900"/>
+              </a:spcAft>
+              <a:buNone/>
+            </a:pPr>
+            <a:r>
+              <a:rPr lang="en-US" sz="1500" b="1" dirty="0">
+                <a:solidFill>
+                  <a:schemeClr val="tx2"/>
+                </a:solidFill>
+              </a:rPr>
+              <a:t>A shared link</a:t>
+            </a:r>
+            <a:endParaRPr lang="en-US" sz="1500" dirty="0"/>
+          </a:p>
+          <a:p>
+            <a:pPr algn="l" indent="0" marL="0">
+              <a:spcAft>
+                <a:spcPts val="900"/>
+              </a:spcAft>
+              <a:buNone/>
+            </a:pPr>
+            <a:r>
+              <a:rPr lang="en-US" sz="1250" dirty="0">
+                <a:solidFill>
+                  <a:schemeClr val="tx1"/>
+                </a:solidFill>
+              </a:rPr>
+              <a:t>At most 40 model questions a minute per visitor; a rejected API key now says so; cover photo 2.4 MB to 195 KB.</a:t>
+            </a:r>
+            <a:endParaRPr lang="en-US" sz="1500" dirty="0"/>
+          </a:p>
+        </p:txBody>
+      </p:sp>
+      <p:sp>
+        <p:nvSpPr>
+          <p:cNvPr id="11" name="Readiness box"/>
+          <p:cNvSpPr/>
+          <p:nvPr/>
+        </p:nvSpPr>
+        <p:spPr>
+          <a:xfrm>
+            <a:off x="6848883" y="4846320"/>
+            <a:ext cx="4791429" cy="1005840"/>
+          </a:xfrm>
+          <a:prstGeom prst="roundRect">
+            <a:avLst>
+              <a:gd name="adj" fmla="val 7273"/>
+            </a:avLst>
+          </a:prstGeom>
+          <a:solidFill>
+            <a:schemeClr val="tx2"/>
+          </a:solidFill>
+          <a:ln/>
+        </p:spPr>
+      </p:sp>
+      <p:sp>
+        <p:nvSpPr>
+          <p:cNvPr id="12" name="Readiness text"/>
+          <p:cNvSpPr txBox="1"/>
+          <p:nvPr/>
+        </p:nvSpPr>
+        <p:spPr>
+          <a:xfrm>
+            <a:off x="7031763" y="4846320"/>
+            <a:ext cx="4425669" cy="1005840"/>
+          </a:xfrm>
+          <a:prstGeom prst="rect">
+            <a:avLst/>
+          </a:prstGeom>
+          <a:noFill/>
+          <a:ln/>
+        </p:spPr>
+        <p:txBody>
+          <a:bodyPr wrap="square" lIns="0" tIns="0" rIns="0" bIns="0" rtlCol="0" anchor="ctr"/>
+          <a:lstStyle/>
+          <a:p>
+            <a:pPr algn="l" indent="0" marL="0">
+              <a:spcAft>
+                <a:spcPts val="400"/>
+              </a:spcAft>
+              <a:buNone/>
+            </a:pPr>
+            <a:r>
+              <a:rPr lang="en-US" sz="1250" b="1" dirty="0">
+                <a:solidFill>
+                  <a:schemeClr val="accent3"/>
+                </a:solidFill>
+              </a:rPr>
+              <a:t>Tested: </a:t>
+            </a:r>
+            <a:pPr algn="l" indent="0" marL="0">
+              <a:spcAft>
+                <a:spcPts val="400"/>
+              </a:spcAft>
+              <a:buNone/>
+            </a:pPr>
+            <a:r>
+              <a:rPr lang="en-US" sz="1250" dirty="0">
+                <a:solidFill>
+                  <a:schemeClr val="bg1"/>
+                </a:solidFill>
+              </a:rPr>
+              <a:t>198 and 136 tests pass on the merged code (pull request #4). </a:t>
+            </a:r>
+            <a:endParaRPr lang="en-US" sz="1250" dirty="0"/>
+          </a:p>
+          <a:p>
+            <a:pPr algn="l" indent="0" marL="0">
+              <a:spcAft>
+                <a:spcPts val="400"/>
+              </a:spcAft>
+              <a:buNone/>
+            </a:pPr>
+            <a:r>
+              <a:rPr lang="en-US" sz="1250" b="1" dirty="0">
+                <a:solidFill>
+                  <a:schemeClr val="accent3"/>
+                </a:solidFill>
+              </a:rPr>
+              <a:t>Not yet tried: </a:t>
+            </a:r>
+            <a:pPr algn="l" indent="0" marL="0">
+              <a:spcAft>
+                <a:spcPts val="400"/>
+              </a:spcAft>
+              <a:buNone/>
+            </a:pPr>
+            <a:r>
+              <a:rPr lang="en-US" sz="1250" dirty="0">
+                <a:solidFill>
+                  <a:schemeClr val="bg1"/>
+                </a:solidFill>
+              </a:rPr>
+              <a:t>a real Outlook window with a team account.</a:t>
+            </a:r>
+            <a:endParaRPr lang="en-US" sz="1250" dirty="0"/>
+          </a:p>
+        </p:txBody>
+      </p:sp>
+      <p:sp>
+        <p:nvSpPr>
+          <p:cNvPr id="13" name="Readiness pointer"/>
+          <p:cNvSpPr txBox="1"/>
+          <p:nvPr/>
+        </p:nvSpPr>
+        <p:spPr>
+          <a:xfrm>
+            <a:off x="548640" y="6053328"/>
+            <a:ext cx="11091672" cy="256032"/>
+          </a:xfrm>
+          <a:prstGeom prst="rect">
+            <a:avLst/>
+          </a:prstGeom>
+          <a:noFill/>
+          <a:ln/>
+        </p:spPr>
+        <p:txBody>
+          <a:bodyPr wrap="square" lIns="0" tIns="0" rIns="0" bIns="0" rtlCol="0" anchor="t"/>
+          <a:lstStyle/>
+          <a:p>
+            <a:pPr algn="l" indent="0" marL="0">
+              <a:buNone/>
+            </a:pPr>
+            <a:r>
+              <a:rPr lang="en-US" sz="1100" dirty="0">
+                <a:solidFill>
+                  <a:schemeClr val="accent5"/>
+                </a:solidFill>
+              </a:rPr>
+              <a:t>Setup and security: docs/outlook_setup.md.</a:t>
+            </a:r>
+            <a:endParaRPr lang="en-US" sz="1100" dirty="0"/>
+          </a:p>
+        </p:txBody>
+      </p:sp>
+      <p:sp>
+        <p:nvSpPr>
+          <p:cNvPr id="25" name="Slide Number Placeholder 0"/>
+          <p:cNvSpPr>
+            <a:spLocks noGrp="1"/>
+          </p:cNvSpPr>
+          <p:nvPr>
+            <p:ph type="sldNum" sz="quarter" idx="4294967295"/>
+          </p:nvPr>
+        </p:nvSpPr>
+        <p:spPr>
+          <a:xfrm>
+            <a:off x="11137392" y="6382512"/>
+            <a:ext cx="502920" cy="274320"/>
+          </a:xfrm>
+          <a:prstGeom prst="rect">
+            <a:avLst/>
+          </a:prstGeom>
+          <a:extLst>
+            <a:ext uri="{C572A759-6A51-4108-AA02-DFA0A04FC94B}">
+              <ma14:wrappingTextBoxFlag xmlns:ma14="http://schemas.microsoft.com/office/mac/drawingml/2011/main" val="0"/>
+            </a:ext>
+          </a:extLst>
+        </p:spPr>
+        <p:txBody>
+          <a:bodyPr/>
+          <a:lstStyle>
+            <a:lvl1pPr>
+              <a:defRPr sz="1000">
+                <a:solidFill>
+                  <a:schemeClr val="accent5"/>
+                </a:solidFill>
+              </a:defRPr>
+            </a:lvl1pPr>
+          </a:lstStyle>
+          <a:p>
+            <a:pPr algn="r"/>
+            <a:fld id="{F7021451-1387-4CA6-816F-3879F97B5CBC}" type="slidenum">
+              <a:rPr b="0" lang="en-US"/>
+              <a:t>13</a:t>
+            </a:fld>
+            <a:endParaRPr lang="en-US"/>
+          </a:p>
+        </p:txBody>
+      </p:sp>
+    </p:spTree>
+  </p:cSld>
+  <p:clrMapOvr>
+    <a:masterClrMapping/>
+  </p:clrMapOvr>
+</p:sld>
+</file>
+
 <file path=ppt/slides/slide2.xml><?xml version="1.0" encoding="utf-8"?>
 <p:sld xmlns:a="http://schemas.openxmlformats.org/drawingml/2006/main" xmlns:r="http://schemas.openxmlformats.org/officeDocument/2006/relationships" xmlns:p="http://schemas.openxmlformats.org/presentationml/2006/main">
   <p:cSld name="Slide 2">
@@ -5039,8 +5734,8 @@
         </p:nvSpPr>
         <p:spPr>
           <a:xfrm>
-            <a:off x="4565904" y="3017520"/>
-            <a:ext cx="3057144" cy="2926080"/>
+            <a:off x="4565904" y="2926080"/>
+            <a:ext cx="3057144" cy="3063240"/>
           </a:xfrm>
           <a:prstGeom prst="rect">
             <a:avLst/>
@@ -5054,138 +5749,172 @@
           <a:p>
             <a:pPr algn="l" indent="0" marL="0">
               <a:spcAft>
-                <a:spcPts val="700"/>
+                <a:spcPts val="300"/>
               </a:spcAft>
               <a:buNone/>
             </a:pPr>
             <a:r>
-              <a:rPr lang="en-US" sz="1300" b="1" dirty="0">
+              <a:rPr lang="en-US" sz="1250" b="1" dirty="0">
                 <a:solidFill>
                   <a:schemeClr val="tx2"/>
                 </a:solidFill>
               </a:rPr>
               <a:t>07:00 briefing</a:t>
             </a:r>
-            <a:endParaRPr lang="en-US" sz="1300" dirty="0"/>
+            <a:endParaRPr lang="en-US" sz="1250" dirty="0"/>
           </a:p>
           <a:p>
             <a:pPr algn="l" indent="0" marL="0">
               <a:spcAft>
-                <a:spcPts val="700"/>
+                <a:spcPts val="300"/>
               </a:spcAft>
               <a:buNone/>
             </a:pPr>
             <a:r>
-              <a:rPr lang="en-US" sz="1300" dirty="0">
+              <a:rPr lang="en-US" sz="1250" dirty="0">
                 <a:solidFill>
                   <a:schemeClr val="tx1"/>
                 </a:solidFill>
               </a:rPr>
-              <a:t>Three lines: yesterday, the top issue, what to decide.</a:t>
-            </a:r>
-            <a:endParaRPr lang="en-US" sz="1300" dirty="0"/>
+              <a:t>Three lines: yesterday, top issue, what to decide.</a:t>
+            </a:r>
+            <a:endParaRPr lang="en-US" sz="1250" dirty="0"/>
           </a:p>
           <a:p>
             <a:pPr algn="l" indent="0" marL="0">
               <a:spcAft>
-                <a:spcPts val="700"/>
+                <a:spcPts val="300"/>
               </a:spcAft>
               <a:buNone/>
             </a:pPr>
             <a:r>
-              <a:rPr lang="en-US" sz="1300" b="1" dirty="0">
+              <a:rPr lang="en-US" sz="1250" b="1" dirty="0">
                 <a:solidFill>
                   <a:schemeClr val="tx2"/>
                 </a:solidFill>
               </a:rPr>
               <a:t>Chat that is honest</a:t>
             </a:r>
-            <a:endParaRPr lang="en-US" sz="1300" dirty="0"/>
+            <a:endParaRPr lang="en-US" sz="1250" dirty="0"/>
           </a:p>
           <a:p>
             <a:pPr algn="l" indent="0" marL="0">
               <a:spcAft>
-                <a:spcPts val="700"/>
+                <a:spcPts val="300"/>
               </a:spcAft>
               <a:buNone/>
             </a:pPr>
             <a:r>
-              <a:rPr lang="en-US" sz="1300" dirty="0">
+              <a:rPr lang="en-US" sz="1250" dirty="0">
                 <a:solidFill>
                   <a:schemeClr val="tx1"/>
                 </a:solidFill>
               </a:rPr>
               <a:t>Asks when unsure, remembers the order in focus, says what the data cannot answer.</a:t>
             </a:r>
-            <a:endParaRPr lang="en-US" sz="1300" dirty="0"/>
+            <a:endParaRPr lang="en-US" sz="1250" dirty="0"/>
           </a:p>
           <a:p>
             <a:pPr algn="l" indent="0" marL="0">
               <a:spcAft>
-                <a:spcPts val="700"/>
+                <a:spcPts val="300"/>
               </a:spcAft>
               <a:buNone/>
             </a:pPr>
             <a:r>
-              <a:rPr lang="en-US" sz="1300" b="1" dirty="0">
+              <a:rPr lang="en-US" sz="1250" b="1" dirty="0">
                 <a:solidFill>
                   <a:schemeClr val="tx2"/>
                 </a:solidFill>
               </a:rPr>
               <a:t>Actions behind a gate</a:t>
             </a:r>
-            <a:endParaRPr lang="en-US" sz="1300" dirty="0"/>
+            <a:endParaRPr lang="en-US" sz="1250" dirty="0"/>
           </a:p>
           <a:p>
             <a:pPr algn="l" indent="0" marL="0">
               <a:spcAft>
-                <a:spcPts val="700"/>
+                <a:spcPts val="300"/>
               </a:spcAft>
               <a:buNone/>
             </a:pPr>
             <a:r>
-              <a:rPr lang="en-US" sz="1300" dirty="0">
+              <a:rPr lang="en-US" sz="1250" dirty="0">
                 <a:solidFill>
                   <a:schemeClr val="tx1"/>
                 </a:solidFill>
               </a:rPr>
               <a:t>A chase-up, note or reminder only after preview, confirm and log.</a:t>
             </a:r>
-            <a:endParaRPr lang="en-US" sz="1300" dirty="0"/>
+            <a:endParaRPr lang="en-US" sz="1250" dirty="0"/>
           </a:p>
           <a:p>
             <a:pPr algn="l" indent="0" marL="0">
               <a:spcAft>
-                <a:spcPts val="700"/>
+                <a:spcPts val="300"/>
               </a:spcAft>
               <a:buNone/>
             </a:pPr>
             <a:r>
-              <a:rPr lang="en-US" sz="1300" b="1" dirty="0">
+              <a:rPr lang="en-US" sz="1250" b="1" dirty="0">
                 <a:solidFill>
                   <a:schemeClr val="tx2"/>
                 </a:solidFill>
               </a:rPr>
               <a:t>Every number traceable</a:t>
             </a:r>
-            <a:endParaRPr lang="en-US" sz="1300" dirty="0"/>
+            <a:endParaRPr lang="en-US" sz="1250" dirty="0"/>
           </a:p>
           <a:p>
             <a:pPr algn="l" indent="0" marL="0">
               <a:spcAft>
-                <a:spcPts val="700"/>
+                <a:spcPts val="300"/>
               </a:spcAft>
               <a:buNone/>
             </a:pPr>
             <a:r>
-              <a:rPr lang="en-US" sz="1300" dirty="0">
+              <a:rPr lang="en-US" sz="1250" dirty="0">
                 <a:solidFill>
                   <a:schemeClr val="tx1"/>
                 </a:solidFill>
               </a:rPr>
               <a:t>It opens the source rows behind it.</a:t>
             </a:r>
-            <a:endParaRPr lang="en-US" sz="1300" dirty="0"/>
+            <a:endParaRPr lang="en-US" sz="1250" dirty="0"/>
+          </a:p>
+          <a:p>
+            <a:pPr algn="l" indent="0" marL="0">
+              <a:spcAft>
+                <a:spcPts val="300"/>
+              </a:spcAft>
+              <a:buNone/>
+            </a:pPr>
+            <a:r>
+              <a:rPr lang="en-US" sz="1250" b="1" dirty="0">
+                <a:solidFill>
+                  <a:schemeClr val="tx2"/>
+                </a:solidFill>
+              </a:rPr>
+              <a:t>Morning email in Outlook</a:t>
+            </a:r>
+            <a:endParaRPr lang="en-US" sz="1250" dirty="0"/>
+          </a:p>
+          <a:p>
+            <a:pPr algn="l" indent="0" marL="0">
+              <a:spcAft>
+                <a:spcPts val="300"/>
+              </a:spcAft>
+              <a:buNone/>
+            </a:pPr>
+            <a:r>
+              <a:rPr lang="en-US" sz="1250" dirty="0">
+                <a:solidFill>
+                  <a:schemeClr val="tx1"/>
+                </a:solidFill>
+              </a:rPr>
+              <a:t>Written from the briefing; opens in Outlook, filled in.</a:t>
+            </a:r>
+            <a:endParaRPr lang="en-US" sz="1250" dirty="0"/>
           </a:p>
         </p:txBody>
       </p:sp>
@@ -6257,7 +6986,7 @@
                   <a:schemeClr val="tx1"/>
                 </a:solidFill>
               </a:rPr>
-              <a:t>Draft, note, reminder: never sent unconfirmed</a:t>
+              <a:t>Chase-up, note, reminder, morning email: never sent unconfirmed</a:t>
             </a:r>
             <a:endParaRPr lang="en-US" sz="1400" dirty="0"/>
           </a:p>
@@ -9180,7 +9909,7 @@
                             <a:schemeClr val="tx1"/>
                           </a:solidFill>
                         </a:rPr>
-                        <a:t>Preview, then a 15-minute single-use confirmation key; every action logged. The chat cannot cancel, delete or change an order.</a:t>
+                        <a:t>Preview, then a 15-minute single-use confirmation key; every action logged. The chat cannot cancel, delete or change an order. The morning email is sent only by the manager, from their own Outlook.</a:t>
                       </a:r>
                       <a:endParaRPr lang="en-US" sz="1250" dirty="0"/>
                     </a:p>
@@ -10101,7 +10830,7 @@
                             <a:schemeClr val="tx1"/>
                           </a:solidFill>
                         </a:rPr>
-                        <a:t>Run the live backend once on the 36 questions and report it as first pass. The demo path (same tools, rules instead of a model) is the fallback.</a:t>
+                        <a:t>Run the live backend once on the 36 questions and report it as first pass. The demo path (same tools, rules instead of a model) is the fallback. On the public link, at most 40 model questions a minute per visitor.</a:t>
                       </a:r>
                       <a:endParaRPr lang="en-US" sz="1250" dirty="0"/>
                     </a:p>
@@ -13280,7 +14009,7 @@
                             <a:schemeClr val="tx1"/>
                           </a:solidFill>
                         </a:rPr>
-                        <a:t>Merge and redeploy, so the briefing and live discovery run on the team's site.</a:t>
+                        <a:t>Pull request #4 is ready: no conflicts, all tests pass on the merged code. Merge, redeploy, run one database step.</a:t>
                       </a:r>
                       <a:endParaRPr lang="en-US" sz="1250" dirty="0"/>
                     </a:p>

</xml_diff>

<commit_message>
Business case in money: planner time, lateness priced, running cost
analysis/business_case.py turns the brief's tasks into planner hours
(triangular ranges, 10,000 draws: about 62 hours a month freed, a third
of a person, S$18.4k a year at Singapore pay plus CPF), prices the
paired simulation's 30.5 working days of lateness avoided per two
months at half of URBN's published 2%-a-day vendor penalty on assumed
FOB prices (S$13.1k a year), and subtracts OpenAI, CloudBase and upkeep
(S$1.9k). Net about S$29.6k a year; a full-time assistant would cost
S$49.1k. Every input carries its source or the word assumption.
docs/business_case.md explains each line and what "30 days of lateness"
means; a test keeps the document equal to the script's output.

Deck: slide 2's business value card shows the figures; new backup
slide 15 shows the calculation.

Co-Authored-By: Claude Opus 5.5 <noreply@anthropic.com>
Claude-Session: https://claude.ai/code/session_01L3rS6UNBGMFNb8LKz3WVVc
</commit_message>
<xml_diff>
--- a/threadpilot/docs/presentation/Presentation_GroupNN_Sprint1.pptx
+++ b/threadpilot/docs/presentation/Presentation_GroupNN_Sprint1.pptx
@@ -19,9 +19,10 @@
     <p:sldId id="267" r:id="rId13"/>
     <p:sldId id="268" r:id="rId14"/>
     <p:sldId id="269" r:id="rId15"/>
+    <p:sldId id="270" r:id="rId16"/>
   </p:sldIdLst>
   <p:notesMasterIdLst>
-    <p:notesMasterId r:id="rId16"/>
+    <p:notesMasterId r:id="rId17"/>
   </p:notesMasterIdLst>
   <p:sldSz cx="12192000" cy="6858000"/>
   <p:notesSz cx="6858000" cy="12192000"/>
@@ -120,7 +121,7 @@
   <p:extLst>
     <p:ext uri="{521415D9-36F7-43E2-AB2F-B90AF26B5E84}">
       <p14:sectionLst xmlns:p14="http://schemas.microsoft.com/office/powerpoint/2010/main">
-        <p14:section name="Sprint 1" id="{1e200046-80d7-2c0c-1784-9b9908b2b797}">
+        <p14:section name="Sprint 1" id="{67221f36-d5f8-2bc9-e0a4-dd6e59e074ff}">
           <p14:sldIdLst>
             <p14:sldId id="256"/>
             <p14:sldId id="257"/>
@@ -133,13 +134,14 @@
             <p14:sldId id="264"/>
           </p14:sldIdLst>
         </p14:section>
-        <p14:section name="Backup" id="{2bc55228-5436-749c-a324-804d8a8f3489}">
+        <p14:section name="Backup" id="{2e733fcd-6c5e-4782-7a7e-8e01883fde65}">
           <p14:sldIdLst>
             <p14:sldId id="265"/>
             <p14:sldId id="266"/>
             <p14:sldId id="267"/>
             <p14:sldId id="268"/>
             <p14:sldId id="269"/>
+            <p14:sldId id="270"/>
           </p14:sldIdLst>
         </p14:section>
       </p14:sectionLst>
@@ -1389,6 +1391,97 @@
 </p:notes>
 </file>
 
+<file path=ppt/notesSlides/notesSlide15.xml><?xml version="1.0" encoding="utf-8"?>
+<p:notes xmlns:a="http://schemas.openxmlformats.org/drawingml/2006/main" xmlns:r="http://schemas.openxmlformats.org/officeDocument/2006/relationships" xmlns:p="http://schemas.openxmlformats.org/presentationml/2006/main">
+  <p:cSld>
+    <p:spTree>
+      <p:nvGrpSpPr>
+        <p:cNvPr id="1" name=""/>
+        <p:cNvGrpSpPr/>
+        <p:nvPr/>
+      </p:nvGrpSpPr>
+      <p:grpSpPr>
+        <a:xfrm>
+          <a:off x="0" y="0"/>
+          <a:ext cx="0" cy="0"/>
+          <a:chOff x="0" y="0"/>
+          <a:chExt cx="0" cy="0"/>
+        </a:xfrm>
+      </p:grpSpPr>
+      <p:sp>
+        <p:nvSpPr>
+          <p:cNvPr id="2" name="Slide Image Placeholder 1"/>
+          <p:cNvSpPr>
+            <a:spLocks noGrp="1" noRot="1" noChangeAspect="1"/>
+          </p:cNvSpPr>
+          <p:nvPr>
+            <p:ph type="sldImg"/>
+          </p:nvPr>
+        </p:nvSpPr>
+        <p:spPr/>
+      </p:sp>
+      <p:sp>
+        <p:nvSpPr>
+          <p:cNvPr id="3" name="Notes Placeholder 2"/>
+          <p:cNvSpPr>
+            <a:spLocks noGrp="1"/>
+          </p:cNvSpPr>
+          <p:nvPr>
+            <p:ph type="body" idx="1"/>
+          </p:nvPr>
+        </p:nvSpPr>
+        <p:spPr/>
+        <p:txBody>
+          <a:bodyPr/>
+          <a:lstStyle/>
+          <a:p>
+            <a:r>
+              <a:rPr lang="en-US" dirty="0"/>
+              <a:t>Backup. Use if asked how the business value was calculated.
+Left: the planner's work today, from the brief's five questions and its 'half hour every morning'. Each task has a low, likely and high time; drawing 10,000 combinations gives about 62 hours a month saved, between 51 and 75. At a Singapore planner's pay plus CPF that is about S$18.4k a year.
+Right: the lateness number. We run the same simulated two months twice with the same random problems, once noticed by a weekly check and once by the briefing. Adding up how many working days every order finished late, the briefing version is about 30 days lower, every two months, across about 88 orders. The 95% range 18 to 43 comes from 40 different runs. We price a day of lateness at half of Urban Outfitters' published 2% a day vendor penalty.
+Be clear: these are estimates. The next step is to time a real planner for a week.</a:t>
+            </a:r>
+            <a:endParaRPr lang="en-US" dirty="0"/>
+          </a:p>
+        </p:txBody>
+      </p:sp>
+      <p:sp>
+        <p:nvSpPr>
+          <p:cNvPr id="4" name="Slide Number Placeholder 3"/>
+          <p:cNvSpPr>
+            <a:spLocks noGrp="1"/>
+          </p:cNvSpPr>
+          <p:nvPr>
+            <p:ph type="sldNum" sz="quarter" idx="10"/>
+          </p:nvPr>
+        </p:nvSpPr>
+        <p:spPr/>
+        <p:txBody>
+          <a:bodyPr/>
+          <a:lstStyle/>
+          <a:p>
+            <a:fld id="{F7021451-1387-4CA6-816F-3879F97B5CBC}" type="slidenum">
+              <a:rPr lang="en-US"/>
+              <a:t>15</a:t>
+            </a:fld>
+            <a:endParaRPr lang="en-US"/>
+          </a:p>
+        </p:txBody>
+      </p:sp>
+    </p:spTree>
+    <p:extLst>
+      <p:ext uri="{BB962C8B-B14F-4D97-AF65-F5344CB8AC3E}">
+        <p14:creationId xmlns:p14="http://schemas.microsoft.com/office/powerpoint/2010/main" val="1024086991"/>
+      </p:ext>
+    </p:extLst>
+  </p:cSld>
+  <p:clrMapOvr>
+    <a:masterClrMapping/>
+  </p:clrMapOvr>
+</p:notes>
+</file>
+
 <file path=ppt/notesSlides/notesSlide2.xml><?xml version="1.0" encoding="utf-8"?>
 <p:notes xmlns:a="http://schemas.openxmlformats.org/drawingml/2006/main" xmlns:r="http://schemas.openxmlformats.org/officeDocument/2006/relationships" xmlns:p="http://schemas.openxmlformats.org/presentationml/2006/main">
   <p:cSld>
@@ -1438,7 +1531,8 @@
               <a:t>~35 seconds.
 The brief gives five questions a general manager asks across a day. Today each one costs a phone call to a planner and a wait, and the answer is sometimes wrong.
 Our solution is an agent the manager talks to: a morning briefing, a chat that asks when unsure and says what the data cannot answer, and actions only after a confirmation. The morning summary goes out as an email from the manager's own Outlook.
-The value, in the brief's words, is the planner's half hour every morning plus every 'let me check and call you back'. We answer all five questions in the demo. We cannot yet show hours saved: no real manager has used it. In a paired simulation, finding problems through the briefing avoided about 30 working days of lateness per two months.</a:t>
+Business value, in money: about S$29.6k a year for one factory. Two parts. First, the planner's time: the morning report and every 'let me check and call you back' add up to about 62 hours a month, a third of a person, about S$18.4k a year at Singapore pay. Second, lateness: in our simulator, finding problems through the briefing cut about 30 working days of lateness every two months; at half of a real retailer's late penalty that is about S$13.1k a year. Running it costs about S$1.9k. These are estimates: the task times and selling prices are assumptions, and backup slide 15 shows every line.
+(If asked about hiring: a full-time assistant to give the same on-call answers would cost about S$49.1k a year.)</a:t>
             </a:r>
             <a:endParaRPr lang="en-US" dirty="0"/>
           </a:p>
@@ -6540,6 +6634,3053 @@
 </p:sld>
 </file>
 
+<file path=ppt/slides/slide15.xml><?xml version="1.0" encoding="utf-8"?>
+<p:sld xmlns:a="http://schemas.openxmlformats.org/drawingml/2006/main" xmlns:r="http://schemas.openxmlformats.org/officeDocument/2006/relationships" xmlns:p="http://schemas.openxmlformats.org/presentationml/2006/main">
+  <p:cSld name="Slide 15">
+    <p:spTree>
+      <p:nvGrpSpPr>
+        <p:cNvPr id="1" name=""/>
+        <p:cNvGrpSpPr/>
+        <p:nvPr/>
+      </p:nvGrpSpPr>
+      <p:grpSpPr>
+        <a:xfrm>
+          <a:off x="0" y="0"/>
+          <a:ext cx="0" cy="0"/>
+          <a:chOff x="0" y="0"/>
+          <a:chExt cx="0" cy="0"/>
+        </a:xfrm>
+      </p:grpSpPr>
+      <p:sp>
+        <p:nvSpPr>
+          <p:cNvPr id="2" name="Text 0"/>
+          <p:cNvSpPr/>
+          <p:nvPr>
+            <p:ph idx="100" type="title" hasCustomPrompt="1"/>
+          </p:nvPr>
+        </p:nvSpPr>
+        <p:spPr>
+          <a:xfrm>
+            <a:off x="548640" y="320040"/>
+            <a:ext cx="11091672" cy="822960"/>
+          </a:xfrm>
+          <a:prstGeom prst="rect">
+            <a:avLst/>
+          </a:prstGeom>
+          <a:noFill/>
+          <a:ln/>
+        </p:spPr>
+        <p:txBody>
+          <a:bodyPr wrap="square" lIns="0" tIns="0" rIns="0" bIns="0" rtlCol="0" anchor="ctr"/>
+          <a:lstStyle/>
+          <a:p>
+            <a:pPr algn="l" indent="0" marL="0">
+              <a:buNone/>
+            </a:pPr>
+            <a:r>
+              <a:rPr lang="en-US" sz="3200" b="1" dirty="0">
+                <a:solidFill>
+                  <a:schemeClr val="tx2"/>
+                </a:solidFill>
+              </a:rPr>
+              <a:t>Backup: the business case, line by line</a:t>
+            </a:r>
+            <a:endParaRPr lang="en-US" sz="3200" dirty="0"/>
+          </a:p>
+        </p:txBody>
+      </p:sp>
+      <p:sp>
+        <p:nvSpPr>
+          <p:cNvPr id="3" name="Backup tag"/>
+          <p:cNvSpPr txBox="1"/>
+          <p:nvPr/>
+        </p:nvSpPr>
+        <p:spPr>
+          <a:xfrm>
+            <a:off x="10515600" y="566928"/>
+            <a:ext cx="1124712" cy="292608"/>
+          </a:xfrm>
+          <a:prstGeom prst="roundRect">
+            <a:avLst>
+              <a:gd name="adj" fmla="val 31250"/>
+            </a:avLst>
+          </a:prstGeom>
+          <a:solidFill>
+            <a:schemeClr val="accent5"/>
+          </a:solidFill>
+          <a:ln/>
+        </p:spPr>
+        <p:txBody>
+          <a:bodyPr wrap="square" lIns="0" tIns="0" rIns="0" bIns="0" rtlCol="0" anchor="ctr"/>
+          <a:lstStyle/>
+          <a:p>
+            <a:pPr algn="ctr" indent="0" marL="0">
+              <a:buNone/>
+            </a:pPr>
+            <a:r>
+              <a:rPr lang="en-US" sz="1100" b="1" dirty="0">
+                <a:solidFill>
+                  <a:schemeClr val="bg1"/>
+                </a:solidFill>
+              </a:rPr>
+              <a:t>BACKUP</a:t>
+            </a:r>
+            <a:endParaRPr lang="en-US" sz="1100" dirty="0"/>
+          </a:p>
+        </p:txBody>
+      </p:sp>
+      <p:sp>
+        <p:nvSpPr>
+          <p:cNvPr id="4" name="Label"/>
+          <p:cNvSpPr txBox="1"/>
+          <p:nvPr/>
+        </p:nvSpPr>
+        <p:spPr>
+          <a:xfrm>
+            <a:off x="548640" y="1234440"/>
+            <a:ext cx="6583680" cy="365760"/>
+          </a:xfrm>
+          <a:prstGeom prst="rect">
+            <a:avLst/>
+          </a:prstGeom>
+          <a:noFill/>
+          <a:ln/>
+        </p:spPr>
+        <p:txBody>
+          <a:bodyPr wrap="square" lIns="0" tIns="0" rIns="0" bIns="0" rtlCol="0" anchor="ctr"/>
+          <a:lstStyle/>
+          <a:p>
+            <a:pPr algn="l" indent="0" marL="0">
+              <a:buNone/>
+            </a:pPr>
+            <a:r>
+              <a:rPr lang="en-US" sz="1500" b="1" dirty="0">
+                <a:solidFill>
+                  <a:schemeClr val="tx2"/>
+                </a:solidFill>
+              </a:rPr>
+              <a:t>1. Planner time: what a person does today, per factory day</a:t>
+            </a:r>
+            <a:endParaRPr lang="en-US" sz="1500" dirty="0"/>
+          </a:p>
+        </p:txBody>
+      </p:sp>
+      <p:graphicFrame>
+        <p:nvGraphicFramePr>
+          <p:cNvPr id="16" name="Task table"/>
+          <p:cNvGraphicFramePr>
+            <a:graphicFrameLocks noGrp="1"/>
+          </p:cNvGraphicFramePr>
+          <p:nvPr>
+            <p:extLst>
+              <p:ext uri="{D42A27DB-BD31-4B8C-83A1-F6EECF244321}">
+                <p14:modId xmlns:p14="http://schemas.microsoft.com/office/powerpoint/2010/main" val="1579011935"/>
+              </p:ext>
+            </p:extLst>
+          </p:nvPr>
+        </p:nvGraphicFramePr>
+        <p:xfrm>
+          <a:off x="548640" y="1645920"/>
+          <a:ext cx="6583680" cy="914400"/>
+        </p:xfrm>
+        <a:graphic>
+          <a:graphicData uri="http://schemas.openxmlformats.org/drawingml/2006/table">
+            <a:tbl>
+              <a:tblPr/>
+              <a:tblGrid>
+                <a:gridCol w="2834640"/>
+                <a:gridCol w="1005840"/>
+                <a:gridCol w="1005840"/>
+                <a:gridCol w="1737360"/>
+              </a:tblGrid>
+              <a:tr h="310896">
+                <a:tc>
+                  <a:txBody>
+                    <a:bodyPr/>
+                    <a:lstStyle/>
+                    <a:p>
+                      <a:pPr algn="l" indent="0" marL="0">
+                        <a:buNone/>
+                      </a:pPr>
+                      <a:r>
+                        <a:rPr lang="en-US" sz="1300" b="1" dirty="0">
+                          <a:solidFill>
+                            <a:schemeClr val="bg1"/>
+                          </a:solidFill>
+                        </a:rPr>
+                        <a:t>Task (likely case)</a:t>
+                      </a:r>
+                      <a:endParaRPr lang="en-US" sz="1300" dirty="0"/>
+                    </a:p>
+                  </a:txBody>
+                  <a:tcPr marL="101600" marR="101600" marT="50800" marB="50800" anchor="ctr">
+                    <a:lnL w="9525" cap="flat" cmpd="sng" algn="ctr">
+                      <a:solidFill>
+                        <a:srgbClr val="EAF2F2"/>
+                      </a:solidFill>
+                      <a:prstDash val="solid"/>
+                      <a:round/>
+                      <a:headEnd type="none" w="med" len="med"/>
+                      <a:tailEnd type="none" w="med" len="med"/>
+                    </a:lnL>
+                    <a:lnR w="9525" cap="flat" cmpd="sng" algn="ctr">
+                      <a:solidFill>
+                        <a:srgbClr val="EAF2F2"/>
+                      </a:solidFill>
+                      <a:prstDash val="solid"/>
+                      <a:round/>
+                      <a:headEnd type="none" w="med" len="med"/>
+                      <a:tailEnd type="none" w="med" len="med"/>
+                    </a:lnR>
+                    <a:lnT w="9525" cap="flat" cmpd="sng" algn="ctr">
+                      <a:solidFill>
+                        <a:srgbClr val="EAF2F2"/>
+                      </a:solidFill>
+                      <a:prstDash val="solid"/>
+                      <a:round/>
+                      <a:headEnd type="none" w="med" len="med"/>
+                      <a:tailEnd type="none" w="med" len="med"/>
+                    </a:lnT>
+                    <a:lnB w="9525" cap="flat" cmpd="sng" algn="ctr">
+                      <a:solidFill>
+                        <a:srgbClr val="EAF2F2"/>
+                      </a:solidFill>
+                      <a:prstDash val="solid"/>
+                      <a:round/>
+                      <a:headEnd type="none" w="med" len="med"/>
+                      <a:tailEnd type="none" w="med" len="med"/>
+                    </a:lnB>
+                    <a:solidFill>
+                      <a:schemeClr val="tx2"/>
+                    </a:solidFill>
+                  </a:tcPr>
+                </a:tc>
+                <a:tc>
+                  <a:txBody>
+                    <a:bodyPr/>
+                    <a:lstStyle/>
+                    <a:p>
+                      <a:pPr algn="ctr" indent="0" marL="0">
+                        <a:buNone/>
+                      </a:pPr>
+                      <a:r>
+                        <a:rPr lang="en-US" sz="1300" b="1" dirty="0">
+                          <a:solidFill>
+                            <a:schemeClr val="bg1"/>
+                          </a:solidFill>
+                        </a:rPr>
+                        <a:t>Minutes</a:t>
+                      </a:r>
+                      <a:endParaRPr lang="en-US" sz="1300" dirty="0"/>
+                    </a:p>
+                  </a:txBody>
+                  <a:tcPr marL="101600" marR="101600" marT="50800" marB="50800" anchor="ctr">
+                    <a:lnL w="9525" cap="flat" cmpd="sng" algn="ctr">
+                      <a:solidFill>
+                        <a:srgbClr val="EAF2F2"/>
+                      </a:solidFill>
+                      <a:prstDash val="solid"/>
+                      <a:round/>
+                      <a:headEnd type="none" w="med" len="med"/>
+                      <a:tailEnd type="none" w="med" len="med"/>
+                    </a:lnL>
+                    <a:lnR w="9525" cap="flat" cmpd="sng" algn="ctr">
+                      <a:solidFill>
+                        <a:srgbClr val="EAF2F2"/>
+                      </a:solidFill>
+                      <a:prstDash val="solid"/>
+                      <a:round/>
+                      <a:headEnd type="none" w="med" len="med"/>
+                      <a:tailEnd type="none" w="med" len="med"/>
+                    </a:lnR>
+                    <a:lnT w="9525" cap="flat" cmpd="sng" algn="ctr">
+                      <a:solidFill>
+                        <a:srgbClr val="EAF2F2"/>
+                      </a:solidFill>
+                      <a:prstDash val="solid"/>
+                      <a:round/>
+                      <a:headEnd type="none" w="med" len="med"/>
+                      <a:tailEnd type="none" w="med" len="med"/>
+                    </a:lnT>
+                    <a:lnB w="9525" cap="flat" cmpd="sng" algn="ctr">
+                      <a:solidFill>
+                        <a:srgbClr val="EAF2F2"/>
+                      </a:solidFill>
+                      <a:prstDash val="solid"/>
+                      <a:round/>
+                      <a:headEnd type="none" w="med" len="med"/>
+                      <a:tailEnd type="none" w="med" len="med"/>
+                    </a:lnB>
+                    <a:solidFill>
+                      <a:schemeClr val="tx2"/>
+                    </a:solidFill>
+                  </a:tcPr>
+                </a:tc>
+                <a:tc>
+                  <a:txBody>
+                    <a:bodyPr/>
+                    <a:lstStyle/>
+                    <a:p>
+                      <a:pPr algn="ctr" indent="0" marL="0">
+                        <a:buNone/>
+                      </a:pPr>
+                      <a:r>
+                        <a:rPr lang="en-US" sz="1300" b="1" dirty="0">
+                          <a:solidFill>
+                            <a:schemeClr val="bg1"/>
+                          </a:solidFill>
+                        </a:rPr>
+                        <a:t>Per day</a:t>
+                      </a:r>
+                      <a:endParaRPr lang="en-US" sz="1300" dirty="0"/>
+                    </a:p>
+                  </a:txBody>
+                  <a:tcPr marL="101600" marR="101600" marT="50800" marB="50800" anchor="ctr">
+                    <a:lnL w="9525" cap="flat" cmpd="sng" algn="ctr">
+                      <a:solidFill>
+                        <a:srgbClr val="EAF2F2"/>
+                      </a:solidFill>
+                      <a:prstDash val="solid"/>
+                      <a:round/>
+                      <a:headEnd type="none" w="med" len="med"/>
+                      <a:tailEnd type="none" w="med" len="med"/>
+                    </a:lnL>
+                    <a:lnR w="9525" cap="flat" cmpd="sng" algn="ctr">
+                      <a:solidFill>
+                        <a:srgbClr val="EAF2F2"/>
+                      </a:solidFill>
+                      <a:prstDash val="solid"/>
+                      <a:round/>
+                      <a:headEnd type="none" w="med" len="med"/>
+                      <a:tailEnd type="none" w="med" len="med"/>
+                    </a:lnR>
+                    <a:lnT w="9525" cap="flat" cmpd="sng" algn="ctr">
+                      <a:solidFill>
+                        <a:srgbClr val="EAF2F2"/>
+                      </a:solidFill>
+                      <a:prstDash val="solid"/>
+                      <a:round/>
+                      <a:headEnd type="none" w="med" len="med"/>
+                      <a:tailEnd type="none" w="med" len="med"/>
+                    </a:lnT>
+                    <a:lnB w="9525" cap="flat" cmpd="sng" algn="ctr">
+                      <a:solidFill>
+                        <a:srgbClr val="EAF2F2"/>
+                      </a:solidFill>
+                      <a:prstDash val="solid"/>
+                      <a:round/>
+                      <a:headEnd type="none" w="med" len="med"/>
+                      <a:tailEnd type="none" w="med" len="med"/>
+                    </a:lnB>
+                    <a:solidFill>
+                      <a:schemeClr val="tx2"/>
+                    </a:solidFill>
+                  </a:tcPr>
+                </a:tc>
+                <a:tc>
+                  <a:txBody>
+                    <a:bodyPr/>
+                    <a:lstStyle/>
+                    <a:p>
+                      <a:pPr algn="ctr" indent="0" marL="0">
+                        <a:buNone/>
+                      </a:pPr>
+                      <a:r>
+                        <a:rPr lang="en-US" sz="1300" b="1" dirty="0">
+                          <a:solidFill>
+                            <a:schemeClr val="bg1"/>
+                          </a:solidFill>
+                        </a:rPr>
+                        <a:t>With ThreadPilot</a:t>
+                      </a:r>
+                      <a:endParaRPr lang="en-US" sz="1300" dirty="0"/>
+                    </a:p>
+                  </a:txBody>
+                  <a:tcPr marL="101600" marR="101600" marT="50800" marB="50800" anchor="ctr">
+                    <a:lnL w="9525" cap="flat" cmpd="sng" algn="ctr">
+                      <a:solidFill>
+                        <a:srgbClr val="EAF2F2"/>
+                      </a:solidFill>
+                      <a:prstDash val="solid"/>
+                      <a:round/>
+                      <a:headEnd type="none" w="med" len="med"/>
+                      <a:tailEnd type="none" w="med" len="med"/>
+                    </a:lnL>
+                    <a:lnR w="9525" cap="flat" cmpd="sng" algn="ctr">
+                      <a:solidFill>
+                        <a:srgbClr val="EAF2F2"/>
+                      </a:solidFill>
+                      <a:prstDash val="solid"/>
+                      <a:round/>
+                      <a:headEnd type="none" w="med" len="med"/>
+                      <a:tailEnd type="none" w="med" len="med"/>
+                    </a:lnR>
+                    <a:lnT w="9525" cap="flat" cmpd="sng" algn="ctr">
+                      <a:solidFill>
+                        <a:srgbClr val="EAF2F2"/>
+                      </a:solidFill>
+                      <a:prstDash val="solid"/>
+                      <a:round/>
+                      <a:headEnd type="none" w="med" len="med"/>
+                      <a:tailEnd type="none" w="med" len="med"/>
+                    </a:lnT>
+                    <a:lnB w="9525" cap="flat" cmpd="sng" algn="ctr">
+                      <a:solidFill>
+                        <a:srgbClr val="EAF2F2"/>
+                      </a:solidFill>
+                      <a:prstDash val="solid"/>
+                      <a:round/>
+                      <a:headEnd type="none" w="med" len="med"/>
+                      <a:tailEnd type="none" w="med" len="med"/>
+                    </a:lnB>
+                    <a:solidFill>
+                      <a:schemeClr val="tx2"/>
+                    </a:solidFill>
+                  </a:tcPr>
+                </a:tc>
+              </a:tr>
+              <a:tr h="310896">
+                <a:tc>
+                  <a:txBody>
+                    <a:bodyPr/>
+                    <a:lstStyle/>
+                    <a:p>
+                      <a:pPr indent="0" marL="0">
+                        <a:buNone/>
+                      </a:pPr>
+                      <a:r>
+                        <a:rPr lang="en-US" sz="1250" dirty="0">
+                          <a:solidFill>
+                            <a:schemeClr val="tx1"/>
+                          </a:solidFill>
+                        </a:rPr>
+                        <a:t>Morning report</a:t>
+                      </a:r>
+                      <a:endParaRPr lang="en-US" sz="1250" dirty="0"/>
+                    </a:p>
+                  </a:txBody>
+                  <a:tcPr marL="101600" marR="101600" marT="50800" marB="50800" anchor="ctr">
+                    <a:lnL w="9525" cap="flat" cmpd="sng" algn="ctr">
+                      <a:solidFill>
+                        <a:srgbClr val="EAF2F2"/>
+                      </a:solidFill>
+                      <a:prstDash val="solid"/>
+                      <a:round/>
+                      <a:headEnd type="none" w="med" len="med"/>
+                      <a:tailEnd type="none" w="med" len="med"/>
+                    </a:lnL>
+                    <a:lnR w="9525" cap="flat" cmpd="sng" algn="ctr">
+                      <a:solidFill>
+                        <a:srgbClr val="EAF2F2"/>
+                      </a:solidFill>
+                      <a:prstDash val="solid"/>
+                      <a:round/>
+                      <a:headEnd type="none" w="med" len="med"/>
+                      <a:tailEnd type="none" w="med" len="med"/>
+                    </a:lnR>
+                    <a:lnT w="9525" cap="flat" cmpd="sng" algn="ctr">
+                      <a:solidFill>
+                        <a:srgbClr val="EAF2F2"/>
+                      </a:solidFill>
+                      <a:prstDash val="solid"/>
+                      <a:round/>
+                      <a:headEnd type="none" w="med" len="med"/>
+                      <a:tailEnd type="none" w="med" len="med"/>
+                    </a:lnT>
+                    <a:lnB w="9525" cap="flat" cmpd="sng" algn="ctr">
+                      <a:solidFill>
+                        <a:srgbClr val="EAF2F2"/>
+                      </a:solidFill>
+                      <a:prstDash val="solid"/>
+                      <a:round/>
+                      <a:headEnd type="none" w="med" len="med"/>
+                      <a:tailEnd type="none" w="med" len="med"/>
+                    </a:lnB>
+                    <a:solidFill>
+                      <a:schemeClr val="bg1"/>
+                    </a:solidFill>
+                  </a:tcPr>
+                </a:tc>
+                <a:tc>
+                  <a:txBody>
+                    <a:bodyPr/>
+                    <a:lstStyle/>
+                    <a:p>
+                      <a:pPr algn="ctr" indent="0" marL="0">
+                        <a:buNone/>
+                      </a:pPr>
+                      <a:r>
+                        <a:rPr lang="en-US" sz="1250" dirty="0">
+                          <a:solidFill>
+                            <a:schemeClr val="tx1"/>
+                          </a:solidFill>
+                        </a:rPr>
+                        <a:t>30</a:t>
+                      </a:r>
+                      <a:endParaRPr lang="en-US" sz="1250" dirty="0"/>
+                    </a:p>
+                  </a:txBody>
+                  <a:tcPr marL="101600" marR="101600" marT="50800" marB="50800" anchor="ctr">
+                    <a:lnL w="9525" cap="flat" cmpd="sng" algn="ctr">
+                      <a:solidFill>
+                        <a:srgbClr val="EAF2F2"/>
+                      </a:solidFill>
+                      <a:prstDash val="solid"/>
+                      <a:round/>
+                      <a:headEnd type="none" w="med" len="med"/>
+                      <a:tailEnd type="none" w="med" len="med"/>
+                    </a:lnL>
+                    <a:lnR w="9525" cap="flat" cmpd="sng" algn="ctr">
+                      <a:solidFill>
+                        <a:srgbClr val="EAF2F2"/>
+                      </a:solidFill>
+                      <a:prstDash val="solid"/>
+                      <a:round/>
+                      <a:headEnd type="none" w="med" len="med"/>
+                      <a:tailEnd type="none" w="med" len="med"/>
+                    </a:lnR>
+                    <a:lnT w="9525" cap="flat" cmpd="sng" algn="ctr">
+                      <a:solidFill>
+                        <a:srgbClr val="EAF2F2"/>
+                      </a:solidFill>
+                      <a:prstDash val="solid"/>
+                      <a:round/>
+                      <a:headEnd type="none" w="med" len="med"/>
+                      <a:tailEnd type="none" w="med" len="med"/>
+                    </a:lnT>
+                    <a:lnB w="9525" cap="flat" cmpd="sng" algn="ctr">
+                      <a:solidFill>
+                        <a:srgbClr val="EAF2F2"/>
+                      </a:solidFill>
+                      <a:prstDash val="solid"/>
+                      <a:round/>
+                      <a:headEnd type="none" w="med" len="med"/>
+                      <a:tailEnd type="none" w="med" len="med"/>
+                    </a:lnB>
+                    <a:solidFill>
+                      <a:schemeClr val="bg1"/>
+                    </a:solidFill>
+                  </a:tcPr>
+                </a:tc>
+                <a:tc>
+                  <a:txBody>
+                    <a:bodyPr/>
+                    <a:lstStyle/>
+                    <a:p>
+                      <a:pPr algn="ctr" indent="0" marL="0">
+                        <a:buNone/>
+                      </a:pPr>
+                      <a:r>
+                        <a:rPr lang="en-US" sz="1250" dirty="0">
+                          <a:solidFill>
+                            <a:schemeClr val="tx1"/>
+                          </a:solidFill>
+                        </a:rPr>
+                        <a:t>1</a:t>
+                      </a:r>
+                      <a:endParaRPr lang="en-US" sz="1250" dirty="0"/>
+                    </a:p>
+                  </a:txBody>
+                  <a:tcPr marL="101600" marR="101600" marT="50800" marB="50800" anchor="ctr">
+                    <a:lnL w="9525" cap="flat" cmpd="sng" algn="ctr">
+                      <a:solidFill>
+                        <a:srgbClr val="EAF2F2"/>
+                      </a:solidFill>
+                      <a:prstDash val="solid"/>
+                      <a:round/>
+                      <a:headEnd type="none" w="med" len="med"/>
+                      <a:tailEnd type="none" w="med" len="med"/>
+                    </a:lnL>
+                    <a:lnR w="9525" cap="flat" cmpd="sng" algn="ctr">
+                      <a:solidFill>
+                        <a:srgbClr val="EAF2F2"/>
+                      </a:solidFill>
+                      <a:prstDash val="solid"/>
+                      <a:round/>
+                      <a:headEnd type="none" w="med" len="med"/>
+                      <a:tailEnd type="none" w="med" len="med"/>
+                    </a:lnR>
+                    <a:lnT w="9525" cap="flat" cmpd="sng" algn="ctr">
+                      <a:solidFill>
+                        <a:srgbClr val="EAF2F2"/>
+                      </a:solidFill>
+                      <a:prstDash val="solid"/>
+                      <a:round/>
+                      <a:headEnd type="none" w="med" len="med"/>
+                      <a:tailEnd type="none" w="med" len="med"/>
+                    </a:lnT>
+                    <a:lnB w="9525" cap="flat" cmpd="sng" algn="ctr">
+                      <a:solidFill>
+                        <a:srgbClr val="EAF2F2"/>
+                      </a:solidFill>
+                      <a:prstDash val="solid"/>
+                      <a:round/>
+                      <a:headEnd type="none" w="med" len="med"/>
+                      <a:tailEnd type="none" w="med" len="med"/>
+                    </a:lnB>
+                    <a:solidFill>
+                      <a:schemeClr val="bg1"/>
+                    </a:solidFill>
+                  </a:tcPr>
+                </a:tc>
+                <a:tc>
+                  <a:txBody>
+                    <a:bodyPr/>
+                    <a:lstStyle/>
+                    <a:p>
+                      <a:pPr algn="ctr" indent="0" marL="0">
+                        <a:buNone/>
+                      </a:pPr>
+                      <a:r>
+                        <a:rPr lang="en-US" sz="1250" dirty="0">
+                          <a:solidFill>
+                            <a:schemeClr val="tx1"/>
+                          </a:solidFill>
+                        </a:rPr>
+                        <a:t>5 min</a:t>
+                      </a:r>
+                      <a:endParaRPr lang="en-US" sz="1250" dirty="0"/>
+                    </a:p>
+                  </a:txBody>
+                  <a:tcPr marL="101600" marR="101600" marT="50800" marB="50800" anchor="ctr">
+                    <a:lnL w="9525" cap="flat" cmpd="sng" algn="ctr">
+                      <a:solidFill>
+                        <a:srgbClr val="EAF2F2"/>
+                      </a:solidFill>
+                      <a:prstDash val="solid"/>
+                      <a:round/>
+                      <a:headEnd type="none" w="med" len="med"/>
+                      <a:tailEnd type="none" w="med" len="med"/>
+                    </a:lnL>
+                    <a:lnR w="9525" cap="flat" cmpd="sng" algn="ctr">
+                      <a:solidFill>
+                        <a:srgbClr val="EAF2F2"/>
+                      </a:solidFill>
+                      <a:prstDash val="solid"/>
+                      <a:round/>
+                      <a:headEnd type="none" w="med" len="med"/>
+                      <a:tailEnd type="none" w="med" len="med"/>
+                    </a:lnR>
+                    <a:lnT w="9525" cap="flat" cmpd="sng" algn="ctr">
+                      <a:solidFill>
+                        <a:srgbClr val="EAF2F2"/>
+                      </a:solidFill>
+                      <a:prstDash val="solid"/>
+                      <a:round/>
+                      <a:headEnd type="none" w="med" len="med"/>
+                      <a:tailEnd type="none" w="med" len="med"/>
+                    </a:lnT>
+                    <a:lnB w="9525" cap="flat" cmpd="sng" algn="ctr">
+                      <a:solidFill>
+                        <a:srgbClr val="EAF2F2"/>
+                      </a:solidFill>
+                      <a:prstDash val="solid"/>
+                      <a:round/>
+                      <a:headEnd type="none" w="med" len="med"/>
+                      <a:tailEnd type="none" w="med" len="med"/>
+                    </a:lnB>
+                    <a:solidFill>
+                      <a:schemeClr val="bg1"/>
+                    </a:solidFill>
+                  </a:tcPr>
+                </a:tc>
+              </a:tr>
+              <a:tr h="310896">
+                <a:tc>
+                  <a:txBody>
+                    <a:bodyPr/>
+                    <a:lstStyle/>
+                    <a:p>
+                      <a:pPr indent="0" marL="0">
+                        <a:buNone/>
+                      </a:pPr>
+                      <a:r>
+                        <a:rPr lang="en-US" sz="1250" dirty="0">
+                          <a:solidFill>
+                            <a:schemeClr val="tx1"/>
+                          </a:solidFill>
+                        </a:rPr>
+                        <a:t>Order status call-back</a:t>
+                      </a:r>
+                      <a:endParaRPr lang="en-US" sz="1250" dirty="0"/>
+                    </a:p>
+                  </a:txBody>
+                  <a:tcPr marL="101600" marR="101600" marT="50800" marB="50800" anchor="ctr">
+                    <a:lnL w="9525" cap="flat" cmpd="sng" algn="ctr">
+                      <a:solidFill>
+                        <a:srgbClr val="EAF2F2"/>
+                      </a:solidFill>
+                      <a:prstDash val="solid"/>
+                      <a:round/>
+                      <a:headEnd type="none" w="med" len="med"/>
+                      <a:tailEnd type="none" w="med" len="med"/>
+                    </a:lnL>
+                    <a:lnR w="9525" cap="flat" cmpd="sng" algn="ctr">
+                      <a:solidFill>
+                        <a:srgbClr val="EAF2F2"/>
+                      </a:solidFill>
+                      <a:prstDash val="solid"/>
+                      <a:round/>
+                      <a:headEnd type="none" w="med" len="med"/>
+                      <a:tailEnd type="none" w="med" len="med"/>
+                    </a:lnR>
+                    <a:lnT w="9525" cap="flat" cmpd="sng" algn="ctr">
+                      <a:solidFill>
+                        <a:srgbClr val="EAF2F2"/>
+                      </a:solidFill>
+                      <a:prstDash val="solid"/>
+                      <a:round/>
+                      <a:headEnd type="none" w="med" len="med"/>
+                      <a:tailEnd type="none" w="med" len="med"/>
+                    </a:lnT>
+                    <a:lnB w="9525" cap="flat" cmpd="sng" algn="ctr">
+                      <a:solidFill>
+                        <a:srgbClr val="EAF2F2"/>
+                      </a:solidFill>
+                      <a:prstDash val="solid"/>
+                      <a:round/>
+                      <a:headEnd type="none" w="med" len="med"/>
+                      <a:tailEnd type="none" w="med" len="med"/>
+                    </a:lnB>
+                    <a:solidFill>
+                      <a:schemeClr val="bg2"/>
+                    </a:solidFill>
+                  </a:tcPr>
+                </a:tc>
+                <a:tc>
+                  <a:txBody>
+                    <a:bodyPr/>
+                    <a:lstStyle/>
+                    <a:p>
+                      <a:pPr algn="ctr" indent="0" marL="0">
+                        <a:buNone/>
+                      </a:pPr>
+                      <a:r>
+                        <a:rPr lang="en-US" sz="1250" dirty="0">
+                          <a:solidFill>
+                            <a:schemeClr val="tx1"/>
+                          </a:solidFill>
+                        </a:rPr>
+                        <a:t>10</a:t>
+                      </a:r>
+                      <a:endParaRPr lang="en-US" sz="1250" dirty="0"/>
+                    </a:p>
+                  </a:txBody>
+                  <a:tcPr marL="101600" marR="101600" marT="50800" marB="50800" anchor="ctr">
+                    <a:lnL w="9525" cap="flat" cmpd="sng" algn="ctr">
+                      <a:solidFill>
+                        <a:srgbClr val="EAF2F2"/>
+                      </a:solidFill>
+                      <a:prstDash val="solid"/>
+                      <a:round/>
+                      <a:headEnd type="none" w="med" len="med"/>
+                      <a:tailEnd type="none" w="med" len="med"/>
+                    </a:lnL>
+                    <a:lnR w="9525" cap="flat" cmpd="sng" algn="ctr">
+                      <a:solidFill>
+                        <a:srgbClr val="EAF2F2"/>
+                      </a:solidFill>
+                      <a:prstDash val="solid"/>
+                      <a:round/>
+                      <a:headEnd type="none" w="med" len="med"/>
+                      <a:tailEnd type="none" w="med" len="med"/>
+                    </a:lnR>
+                    <a:lnT w="9525" cap="flat" cmpd="sng" algn="ctr">
+                      <a:solidFill>
+                        <a:srgbClr val="EAF2F2"/>
+                      </a:solidFill>
+                      <a:prstDash val="solid"/>
+                      <a:round/>
+                      <a:headEnd type="none" w="med" len="med"/>
+                      <a:tailEnd type="none" w="med" len="med"/>
+                    </a:lnT>
+                    <a:lnB w="9525" cap="flat" cmpd="sng" algn="ctr">
+                      <a:solidFill>
+                        <a:srgbClr val="EAF2F2"/>
+                      </a:solidFill>
+                      <a:prstDash val="solid"/>
+                      <a:round/>
+                      <a:headEnd type="none" w="med" len="med"/>
+                      <a:tailEnd type="none" w="med" len="med"/>
+                    </a:lnB>
+                    <a:solidFill>
+                      <a:schemeClr val="bg2"/>
+                    </a:solidFill>
+                  </a:tcPr>
+                </a:tc>
+                <a:tc>
+                  <a:txBody>
+                    <a:bodyPr/>
+                    <a:lstStyle/>
+                    <a:p>
+                      <a:pPr algn="ctr" indent="0" marL="0">
+                        <a:buNone/>
+                      </a:pPr>
+                      <a:r>
+                        <a:rPr lang="en-US" sz="1250" dirty="0">
+                          <a:solidFill>
+                            <a:schemeClr val="tx1"/>
+                          </a:solidFill>
+                        </a:rPr>
+                        <a:t>3</a:t>
+                      </a:r>
+                      <a:endParaRPr lang="en-US" sz="1250" dirty="0"/>
+                    </a:p>
+                  </a:txBody>
+                  <a:tcPr marL="101600" marR="101600" marT="50800" marB="50800" anchor="ctr">
+                    <a:lnL w="9525" cap="flat" cmpd="sng" algn="ctr">
+                      <a:solidFill>
+                        <a:srgbClr val="EAF2F2"/>
+                      </a:solidFill>
+                      <a:prstDash val="solid"/>
+                      <a:round/>
+                      <a:headEnd type="none" w="med" len="med"/>
+                      <a:tailEnd type="none" w="med" len="med"/>
+                    </a:lnL>
+                    <a:lnR w="9525" cap="flat" cmpd="sng" algn="ctr">
+                      <a:solidFill>
+                        <a:srgbClr val="EAF2F2"/>
+                      </a:solidFill>
+                      <a:prstDash val="solid"/>
+                      <a:round/>
+                      <a:headEnd type="none" w="med" len="med"/>
+                      <a:tailEnd type="none" w="med" len="med"/>
+                    </a:lnR>
+                    <a:lnT w="9525" cap="flat" cmpd="sng" algn="ctr">
+                      <a:solidFill>
+                        <a:srgbClr val="EAF2F2"/>
+                      </a:solidFill>
+                      <a:prstDash val="solid"/>
+                      <a:round/>
+                      <a:headEnd type="none" w="med" len="med"/>
+                      <a:tailEnd type="none" w="med" len="med"/>
+                    </a:lnT>
+                    <a:lnB w="9525" cap="flat" cmpd="sng" algn="ctr">
+                      <a:solidFill>
+                        <a:srgbClr val="EAF2F2"/>
+                      </a:solidFill>
+                      <a:prstDash val="solid"/>
+                      <a:round/>
+                      <a:headEnd type="none" w="med" len="med"/>
+                      <a:tailEnd type="none" w="med" len="med"/>
+                    </a:lnB>
+                    <a:solidFill>
+                      <a:schemeClr val="bg2"/>
+                    </a:solidFill>
+                  </a:tcPr>
+                </a:tc>
+                <a:tc>
+                  <a:txBody>
+                    <a:bodyPr/>
+                    <a:lstStyle/>
+                    <a:p>
+                      <a:pPr algn="ctr" indent="0" marL="0">
+                        <a:buNone/>
+                      </a:pPr>
+                      <a:r>
+                        <a:rPr lang="en-US" sz="1250" dirty="0">
+                          <a:solidFill>
+                            <a:schemeClr val="tx1"/>
+                          </a:solidFill>
+                        </a:rPr>
+                        <a:t>1 min</a:t>
+                      </a:r>
+                      <a:endParaRPr lang="en-US" sz="1250" dirty="0"/>
+                    </a:p>
+                  </a:txBody>
+                  <a:tcPr marL="101600" marR="101600" marT="50800" marB="50800" anchor="ctr">
+                    <a:lnL w="9525" cap="flat" cmpd="sng" algn="ctr">
+                      <a:solidFill>
+                        <a:srgbClr val="EAF2F2"/>
+                      </a:solidFill>
+                      <a:prstDash val="solid"/>
+                      <a:round/>
+                      <a:headEnd type="none" w="med" len="med"/>
+                      <a:tailEnd type="none" w="med" len="med"/>
+                    </a:lnL>
+                    <a:lnR w="9525" cap="flat" cmpd="sng" algn="ctr">
+                      <a:solidFill>
+                        <a:srgbClr val="EAF2F2"/>
+                      </a:solidFill>
+                      <a:prstDash val="solid"/>
+                      <a:round/>
+                      <a:headEnd type="none" w="med" len="med"/>
+                      <a:tailEnd type="none" w="med" len="med"/>
+                    </a:lnR>
+                    <a:lnT w="9525" cap="flat" cmpd="sng" algn="ctr">
+                      <a:solidFill>
+                        <a:srgbClr val="EAF2F2"/>
+                      </a:solidFill>
+                      <a:prstDash val="solid"/>
+                      <a:round/>
+                      <a:headEnd type="none" w="med" len="med"/>
+                      <a:tailEnd type="none" w="med" len="med"/>
+                    </a:lnT>
+                    <a:lnB w="9525" cap="flat" cmpd="sng" algn="ctr">
+                      <a:solidFill>
+                        <a:srgbClr val="EAF2F2"/>
+                      </a:solidFill>
+                      <a:prstDash val="solid"/>
+                      <a:round/>
+                      <a:headEnd type="none" w="med" len="med"/>
+                      <a:tailEnd type="none" w="med" len="med"/>
+                    </a:lnB>
+                    <a:solidFill>
+                      <a:schemeClr val="bg2"/>
+                    </a:solidFill>
+                  </a:tcPr>
+                </a:tc>
+              </a:tr>
+              <a:tr h="310896">
+                <a:tc>
+                  <a:txBody>
+                    <a:bodyPr/>
+                    <a:lstStyle/>
+                    <a:p>
+                      <a:pPr indent="0" marL="0">
+                        <a:buNone/>
+                      </a:pPr>
+                      <a:r>
+                        <a:rPr lang="en-US" sz="1250" dirty="0">
+                          <a:solidFill>
+                            <a:schemeClr val="tx1"/>
+                          </a:solidFill>
+                        </a:rPr>
+                        <a:t>Can we take this order?</a:t>
+                      </a:r>
+                      <a:endParaRPr lang="en-US" sz="1250" dirty="0"/>
+                    </a:p>
+                  </a:txBody>
+                  <a:tcPr marL="101600" marR="101600" marT="50800" marB="50800" anchor="ctr">
+                    <a:lnL w="9525" cap="flat" cmpd="sng" algn="ctr">
+                      <a:solidFill>
+                        <a:srgbClr val="EAF2F2"/>
+                      </a:solidFill>
+                      <a:prstDash val="solid"/>
+                      <a:round/>
+                      <a:headEnd type="none" w="med" len="med"/>
+                      <a:tailEnd type="none" w="med" len="med"/>
+                    </a:lnL>
+                    <a:lnR w="9525" cap="flat" cmpd="sng" algn="ctr">
+                      <a:solidFill>
+                        <a:srgbClr val="EAF2F2"/>
+                      </a:solidFill>
+                      <a:prstDash val="solid"/>
+                      <a:round/>
+                      <a:headEnd type="none" w="med" len="med"/>
+                      <a:tailEnd type="none" w="med" len="med"/>
+                    </a:lnR>
+                    <a:lnT w="9525" cap="flat" cmpd="sng" algn="ctr">
+                      <a:solidFill>
+                        <a:srgbClr val="EAF2F2"/>
+                      </a:solidFill>
+                      <a:prstDash val="solid"/>
+                      <a:round/>
+                      <a:headEnd type="none" w="med" len="med"/>
+                      <a:tailEnd type="none" w="med" len="med"/>
+                    </a:lnT>
+                    <a:lnB w="9525" cap="flat" cmpd="sng" algn="ctr">
+                      <a:solidFill>
+                        <a:srgbClr val="EAF2F2"/>
+                      </a:solidFill>
+                      <a:prstDash val="solid"/>
+                      <a:round/>
+                      <a:headEnd type="none" w="med" len="med"/>
+                      <a:tailEnd type="none" w="med" len="med"/>
+                    </a:lnB>
+                    <a:solidFill>
+                      <a:schemeClr val="bg1"/>
+                    </a:solidFill>
+                  </a:tcPr>
+                </a:tc>
+                <a:tc>
+                  <a:txBody>
+                    <a:bodyPr/>
+                    <a:lstStyle/>
+                    <a:p>
+                      <a:pPr algn="ctr" indent="0" marL="0">
+                        <a:buNone/>
+                      </a:pPr>
+                      <a:r>
+                        <a:rPr lang="en-US" sz="1250" dirty="0">
+                          <a:solidFill>
+                            <a:schemeClr val="tx1"/>
+                          </a:solidFill>
+                        </a:rPr>
+                        <a:t>45</a:t>
+                      </a:r>
+                      <a:endParaRPr lang="en-US" sz="1250" dirty="0"/>
+                    </a:p>
+                  </a:txBody>
+                  <a:tcPr marL="101600" marR="101600" marT="50800" marB="50800" anchor="ctr">
+                    <a:lnL w="9525" cap="flat" cmpd="sng" algn="ctr">
+                      <a:solidFill>
+                        <a:srgbClr val="EAF2F2"/>
+                      </a:solidFill>
+                      <a:prstDash val="solid"/>
+                      <a:round/>
+                      <a:headEnd type="none" w="med" len="med"/>
+                      <a:tailEnd type="none" w="med" len="med"/>
+                    </a:lnL>
+                    <a:lnR w="9525" cap="flat" cmpd="sng" algn="ctr">
+                      <a:solidFill>
+                        <a:srgbClr val="EAF2F2"/>
+                      </a:solidFill>
+                      <a:prstDash val="solid"/>
+                      <a:round/>
+                      <a:headEnd type="none" w="med" len="med"/>
+                      <a:tailEnd type="none" w="med" len="med"/>
+                    </a:lnR>
+                    <a:lnT w="9525" cap="flat" cmpd="sng" algn="ctr">
+                      <a:solidFill>
+                        <a:srgbClr val="EAF2F2"/>
+                      </a:solidFill>
+                      <a:prstDash val="solid"/>
+                      <a:round/>
+                      <a:headEnd type="none" w="med" len="med"/>
+                      <a:tailEnd type="none" w="med" len="med"/>
+                    </a:lnT>
+                    <a:lnB w="9525" cap="flat" cmpd="sng" algn="ctr">
+                      <a:solidFill>
+                        <a:srgbClr val="EAF2F2"/>
+                      </a:solidFill>
+                      <a:prstDash val="solid"/>
+                      <a:round/>
+                      <a:headEnd type="none" w="med" len="med"/>
+                      <a:tailEnd type="none" w="med" len="med"/>
+                    </a:lnB>
+                    <a:solidFill>
+                      <a:schemeClr val="bg1"/>
+                    </a:solidFill>
+                  </a:tcPr>
+                </a:tc>
+                <a:tc>
+                  <a:txBody>
+                    <a:bodyPr/>
+                    <a:lstStyle/>
+                    <a:p>
+                      <a:pPr algn="ctr" indent="0" marL="0">
+                        <a:buNone/>
+                      </a:pPr>
+                      <a:r>
+                        <a:rPr lang="en-US" sz="1250" dirty="0">
+                          <a:solidFill>
+                            <a:schemeClr val="tx1"/>
+                          </a:solidFill>
+                        </a:rPr>
+                        <a:t>0.5</a:t>
+                      </a:r>
+                      <a:endParaRPr lang="en-US" sz="1250" dirty="0"/>
+                    </a:p>
+                  </a:txBody>
+                  <a:tcPr marL="101600" marR="101600" marT="50800" marB="50800" anchor="ctr">
+                    <a:lnL w="9525" cap="flat" cmpd="sng" algn="ctr">
+                      <a:solidFill>
+                        <a:srgbClr val="EAF2F2"/>
+                      </a:solidFill>
+                      <a:prstDash val="solid"/>
+                      <a:round/>
+                      <a:headEnd type="none" w="med" len="med"/>
+                      <a:tailEnd type="none" w="med" len="med"/>
+                    </a:lnL>
+                    <a:lnR w="9525" cap="flat" cmpd="sng" algn="ctr">
+                      <a:solidFill>
+                        <a:srgbClr val="EAF2F2"/>
+                      </a:solidFill>
+                      <a:prstDash val="solid"/>
+                      <a:round/>
+                      <a:headEnd type="none" w="med" len="med"/>
+                      <a:tailEnd type="none" w="med" len="med"/>
+                    </a:lnR>
+                    <a:lnT w="9525" cap="flat" cmpd="sng" algn="ctr">
+                      <a:solidFill>
+                        <a:srgbClr val="EAF2F2"/>
+                      </a:solidFill>
+                      <a:prstDash val="solid"/>
+                      <a:round/>
+                      <a:headEnd type="none" w="med" len="med"/>
+                      <a:tailEnd type="none" w="med" len="med"/>
+                    </a:lnT>
+                    <a:lnB w="9525" cap="flat" cmpd="sng" algn="ctr">
+                      <a:solidFill>
+                        <a:srgbClr val="EAF2F2"/>
+                      </a:solidFill>
+                      <a:prstDash val="solid"/>
+                      <a:round/>
+                      <a:headEnd type="none" w="med" len="med"/>
+                      <a:tailEnd type="none" w="med" len="med"/>
+                    </a:lnB>
+                    <a:solidFill>
+                      <a:schemeClr val="bg1"/>
+                    </a:solidFill>
+                  </a:tcPr>
+                </a:tc>
+                <a:tc>
+                  <a:txBody>
+                    <a:bodyPr/>
+                    <a:lstStyle/>
+                    <a:p>
+                      <a:pPr algn="ctr" indent="0" marL="0">
+                        <a:buNone/>
+                      </a:pPr>
+                      <a:r>
+                        <a:rPr lang="en-US" sz="1250" dirty="0">
+                          <a:solidFill>
+                            <a:schemeClr val="tx1"/>
+                          </a:solidFill>
+                        </a:rPr>
+                        <a:t>10 min</a:t>
+                      </a:r>
+                      <a:endParaRPr lang="en-US" sz="1250" dirty="0"/>
+                    </a:p>
+                  </a:txBody>
+                  <a:tcPr marL="101600" marR="101600" marT="50800" marB="50800" anchor="ctr">
+                    <a:lnL w="9525" cap="flat" cmpd="sng" algn="ctr">
+                      <a:solidFill>
+                        <a:srgbClr val="EAF2F2"/>
+                      </a:solidFill>
+                      <a:prstDash val="solid"/>
+                      <a:round/>
+                      <a:headEnd type="none" w="med" len="med"/>
+                      <a:tailEnd type="none" w="med" len="med"/>
+                    </a:lnL>
+                    <a:lnR w="9525" cap="flat" cmpd="sng" algn="ctr">
+                      <a:solidFill>
+                        <a:srgbClr val="EAF2F2"/>
+                      </a:solidFill>
+                      <a:prstDash val="solid"/>
+                      <a:round/>
+                      <a:headEnd type="none" w="med" len="med"/>
+                      <a:tailEnd type="none" w="med" len="med"/>
+                    </a:lnR>
+                    <a:lnT w="9525" cap="flat" cmpd="sng" algn="ctr">
+                      <a:solidFill>
+                        <a:srgbClr val="EAF2F2"/>
+                      </a:solidFill>
+                      <a:prstDash val="solid"/>
+                      <a:round/>
+                      <a:headEnd type="none" w="med" len="med"/>
+                      <a:tailEnd type="none" w="med" len="med"/>
+                    </a:lnT>
+                    <a:lnB w="9525" cap="flat" cmpd="sng" algn="ctr">
+                      <a:solidFill>
+                        <a:srgbClr val="EAF2F2"/>
+                      </a:solidFill>
+                      <a:prstDash val="solid"/>
+                      <a:round/>
+                      <a:headEnd type="none" w="med" len="med"/>
+                      <a:tailEnd type="none" w="med" len="med"/>
+                    </a:lnB>
+                    <a:solidFill>
+                      <a:schemeClr val="bg1"/>
+                    </a:solidFill>
+                  </a:tcPr>
+                </a:tc>
+              </a:tr>
+              <a:tr h="310896">
+                <a:tc>
+                  <a:txBody>
+                    <a:bodyPr/>
+                    <a:lstStyle/>
+                    <a:p>
+                      <a:pPr indent="0" marL="0">
+                        <a:buNone/>
+                      </a:pPr>
+                      <a:r>
+                        <a:rPr lang="en-US" sz="1250" dirty="0">
+                          <a:solidFill>
+                            <a:schemeClr val="tx1"/>
+                          </a:solidFill>
+                        </a:rPr>
+                        <a:t>Why did a stage drop?</a:t>
+                      </a:r>
+                      <a:endParaRPr lang="en-US" sz="1250" dirty="0"/>
+                    </a:p>
+                  </a:txBody>
+                  <a:tcPr marL="101600" marR="101600" marT="50800" marB="50800" anchor="ctr">
+                    <a:lnL w="9525" cap="flat" cmpd="sng" algn="ctr">
+                      <a:solidFill>
+                        <a:srgbClr val="EAF2F2"/>
+                      </a:solidFill>
+                      <a:prstDash val="solid"/>
+                      <a:round/>
+                      <a:headEnd type="none" w="med" len="med"/>
+                      <a:tailEnd type="none" w="med" len="med"/>
+                    </a:lnL>
+                    <a:lnR w="9525" cap="flat" cmpd="sng" algn="ctr">
+                      <a:solidFill>
+                        <a:srgbClr val="EAF2F2"/>
+                      </a:solidFill>
+                      <a:prstDash val="solid"/>
+                      <a:round/>
+                      <a:headEnd type="none" w="med" len="med"/>
+                      <a:tailEnd type="none" w="med" len="med"/>
+                    </a:lnR>
+                    <a:lnT w="9525" cap="flat" cmpd="sng" algn="ctr">
+                      <a:solidFill>
+                        <a:srgbClr val="EAF2F2"/>
+                      </a:solidFill>
+                      <a:prstDash val="solid"/>
+                      <a:round/>
+                      <a:headEnd type="none" w="med" len="med"/>
+                      <a:tailEnd type="none" w="med" len="med"/>
+                    </a:lnT>
+                    <a:lnB w="9525" cap="flat" cmpd="sng" algn="ctr">
+                      <a:solidFill>
+                        <a:srgbClr val="EAF2F2"/>
+                      </a:solidFill>
+                      <a:prstDash val="solid"/>
+                      <a:round/>
+                      <a:headEnd type="none" w="med" len="med"/>
+                      <a:tailEnd type="none" w="med" len="med"/>
+                    </a:lnB>
+                    <a:solidFill>
+                      <a:schemeClr val="bg2"/>
+                    </a:solidFill>
+                  </a:tcPr>
+                </a:tc>
+                <a:tc>
+                  <a:txBody>
+                    <a:bodyPr/>
+                    <a:lstStyle/>
+                    <a:p>
+                      <a:pPr algn="ctr" indent="0" marL="0">
+                        <a:buNone/>
+                      </a:pPr>
+                      <a:r>
+                        <a:rPr lang="en-US" sz="1250" dirty="0">
+                          <a:solidFill>
+                            <a:schemeClr val="tx1"/>
+                          </a:solidFill>
+                        </a:rPr>
+                        <a:t>30</a:t>
+                      </a:r>
+                      <a:endParaRPr lang="en-US" sz="1250" dirty="0"/>
+                    </a:p>
+                  </a:txBody>
+                  <a:tcPr marL="101600" marR="101600" marT="50800" marB="50800" anchor="ctr">
+                    <a:lnL w="9525" cap="flat" cmpd="sng" algn="ctr">
+                      <a:solidFill>
+                        <a:srgbClr val="EAF2F2"/>
+                      </a:solidFill>
+                      <a:prstDash val="solid"/>
+                      <a:round/>
+                      <a:headEnd type="none" w="med" len="med"/>
+                      <a:tailEnd type="none" w="med" len="med"/>
+                    </a:lnL>
+                    <a:lnR w="9525" cap="flat" cmpd="sng" algn="ctr">
+                      <a:solidFill>
+                        <a:srgbClr val="EAF2F2"/>
+                      </a:solidFill>
+                      <a:prstDash val="solid"/>
+                      <a:round/>
+                      <a:headEnd type="none" w="med" len="med"/>
+                      <a:tailEnd type="none" w="med" len="med"/>
+                    </a:lnR>
+                    <a:lnT w="9525" cap="flat" cmpd="sng" algn="ctr">
+                      <a:solidFill>
+                        <a:srgbClr val="EAF2F2"/>
+                      </a:solidFill>
+                      <a:prstDash val="solid"/>
+                      <a:round/>
+                      <a:headEnd type="none" w="med" len="med"/>
+                      <a:tailEnd type="none" w="med" len="med"/>
+                    </a:lnT>
+                    <a:lnB w="9525" cap="flat" cmpd="sng" algn="ctr">
+                      <a:solidFill>
+                        <a:srgbClr val="EAF2F2"/>
+                      </a:solidFill>
+                      <a:prstDash val="solid"/>
+                      <a:round/>
+                      <a:headEnd type="none" w="med" len="med"/>
+                      <a:tailEnd type="none" w="med" len="med"/>
+                    </a:lnB>
+                    <a:solidFill>
+                      <a:schemeClr val="bg2"/>
+                    </a:solidFill>
+                  </a:tcPr>
+                </a:tc>
+                <a:tc>
+                  <a:txBody>
+                    <a:bodyPr/>
+                    <a:lstStyle/>
+                    <a:p>
+                      <a:pPr algn="ctr" indent="0" marL="0">
+                        <a:buNone/>
+                      </a:pPr>
+                      <a:r>
+                        <a:rPr lang="en-US" sz="1250" dirty="0">
+                          <a:solidFill>
+                            <a:schemeClr val="tx1"/>
+                          </a:solidFill>
+                        </a:rPr>
+                        <a:t>0.5</a:t>
+                      </a:r>
+                      <a:endParaRPr lang="en-US" sz="1250" dirty="0"/>
+                    </a:p>
+                  </a:txBody>
+                  <a:tcPr marL="101600" marR="101600" marT="50800" marB="50800" anchor="ctr">
+                    <a:lnL w="9525" cap="flat" cmpd="sng" algn="ctr">
+                      <a:solidFill>
+                        <a:srgbClr val="EAF2F2"/>
+                      </a:solidFill>
+                      <a:prstDash val="solid"/>
+                      <a:round/>
+                      <a:headEnd type="none" w="med" len="med"/>
+                      <a:tailEnd type="none" w="med" len="med"/>
+                    </a:lnL>
+                    <a:lnR w="9525" cap="flat" cmpd="sng" algn="ctr">
+                      <a:solidFill>
+                        <a:srgbClr val="EAF2F2"/>
+                      </a:solidFill>
+                      <a:prstDash val="solid"/>
+                      <a:round/>
+                      <a:headEnd type="none" w="med" len="med"/>
+                      <a:tailEnd type="none" w="med" len="med"/>
+                    </a:lnR>
+                    <a:lnT w="9525" cap="flat" cmpd="sng" algn="ctr">
+                      <a:solidFill>
+                        <a:srgbClr val="EAF2F2"/>
+                      </a:solidFill>
+                      <a:prstDash val="solid"/>
+                      <a:round/>
+                      <a:headEnd type="none" w="med" len="med"/>
+                      <a:tailEnd type="none" w="med" len="med"/>
+                    </a:lnT>
+                    <a:lnB w="9525" cap="flat" cmpd="sng" algn="ctr">
+                      <a:solidFill>
+                        <a:srgbClr val="EAF2F2"/>
+                      </a:solidFill>
+                      <a:prstDash val="solid"/>
+                      <a:round/>
+                      <a:headEnd type="none" w="med" len="med"/>
+                      <a:tailEnd type="none" w="med" len="med"/>
+                    </a:lnB>
+                    <a:solidFill>
+                      <a:schemeClr val="bg2"/>
+                    </a:solidFill>
+                  </a:tcPr>
+                </a:tc>
+                <a:tc>
+                  <a:txBody>
+                    <a:bodyPr/>
+                    <a:lstStyle/>
+                    <a:p>
+                      <a:pPr algn="ctr" indent="0" marL="0">
+                        <a:buNone/>
+                      </a:pPr>
+                      <a:r>
+                        <a:rPr lang="en-US" sz="1250" dirty="0">
+                          <a:solidFill>
+                            <a:schemeClr val="tx1"/>
+                          </a:solidFill>
+                        </a:rPr>
+                        <a:t>5 min</a:t>
+                      </a:r>
+                      <a:endParaRPr lang="en-US" sz="1250" dirty="0"/>
+                    </a:p>
+                  </a:txBody>
+                  <a:tcPr marL="101600" marR="101600" marT="50800" marB="50800" anchor="ctr">
+                    <a:lnL w="9525" cap="flat" cmpd="sng" algn="ctr">
+                      <a:solidFill>
+                        <a:srgbClr val="EAF2F2"/>
+                      </a:solidFill>
+                      <a:prstDash val="solid"/>
+                      <a:round/>
+                      <a:headEnd type="none" w="med" len="med"/>
+                      <a:tailEnd type="none" w="med" len="med"/>
+                    </a:lnL>
+                    <a:lnR w="9525" cap="flat" cmpd="sng" algn="ctr">
+                      <a:solidFill>
+                        <a:srgbClr val="EAF2F2"/>
+                      </a:solidFill>
+                      <a:prstDash val="solid"/>
+                      <a:round/>
+                      <a:headEnd type="none" w="med" len="med"/>
+                      <a:tailEnd type="none" w="med" len="med"/>
+                    </a:lnR>
+                    <a:lnT w="9525" cap="flat" cmpd="sng" algn="ctr">
+                      <a:solidFill>
+                        <a:srgbClr val="EAF2F2"/>
+                      </a:solidFill>
+                      <a:prstDash val="solid"/>
+                      <a:round/>
+                      <a:headEnd type="none" w="med" len="med"/>
+                      <a:tailEnd type="none" w="med" len="med"/>
+                    </a:lnT>
+                    <a:lnB w="9525" cap="flat" cmpd="sng" algn="ctr">
+                      <a:solidFill>
+                        <a:srgbClr val="EAF2F2"/>
+                      </a:solidFill>
+                      <a:prstDash val="solid"/>
+                      <a:round/>
+                      <a:headEnd type="none" w="med" len="med"/>
+                      <a:tailEnd type="none" w="med" len="med"/>
+                    </a:lnB>
+                    <a:solidFill>
+                      <a:schemeClr val="bg2"/>
+                    </a:solidFill>
+                  </a:tcPr>
+                </a:tc>
+              </a:tr>
+              <a:tr h="310896">
+                <a:tc>
+                  <a:txBody>
+                    <a:bodyPr/>
+                    <a:lstStyle/>
+                    <a:p>
+                      <a:pPr indent="0" marL="0">
+                        <a:buNone/>
+                      </a:pPr>
+                      <a:r>
+                        <a:rPr lang="en-US" sz="1250" dirty="0">
+                          <a:solidFill>
+                            <a:schemeClr val="tx1"/>
+                          </a:solidFill>
+                        </a:rPr>
+                        <a:t>Chase-up message</a:t>
+                      </a:r>
+                      <a:endParaRPr lang="en-US" sz="1250" dirty="0"/>
+                    </a:p>
+                  </a:txBody>
+                  <a:tcPr marL="101600" marR="101600" marT="50800" marB="50800" anchor="ctr">
+                    <a:lnL w="9525" cap="flat" cmpd="sng" algn="ctr">
+                      <a:solidFill>
+                        <a:srgbClr val="EAF2F2"/>
+                      </a:solidFill>
+                      <a:prstDash val="solid"/>
+                      <a:round/>
+                      <a:headEnd type="none" w="med" len="med"/>
+                      <a:tailEnd type="none" w="med" len="med"/>
+                    </a:lnL>
+                    <a:lnR w="9525" cap="flat" cmpd="sng" algn="ctr">
+                      <a:solidFill>
+                        <a:srgbClr val="EAF2F2"/>
+                      </a:solidFill>
+                      <a:prstDash val="solid"/>
+                      <a:round/>
+                      <a:headEnd type="none" w="med" len="med"/>
+                      <a:tailEnd type="none" w="med" len="med"/>
+                    </a:lnR>
+                    <a:lnT w="9525" cap="flat" cmpd="sng" algn="ctr">
+                      <a:solidFill>
+                        <a:srgbClr val="EAF2F2"/>
+                      </a:solidFill>
+                      <a:prstDash val="solid"/>
+                      <a:round/>
+                      <a:headEnd type="none" w="med" len="med"/>
+                      <a:tailEnd type="none" w="med" len="med"/>
+                    </a:lnT>
+                    <a:lnB w="9525" cap="flat" cmpd="sng" algn="ctr">
+                      <a:solidFill>
+                        <a:srgbClr val="EAF2F2"/>
+                      </a:solidFill>
+                      <a:prstDash val="solid"/>
+                      <a:round/>
+                      <a:headEnd type="none" w="med" len="med"/>
+                      <a:tailEnd type="none" w="med" len="med"/>
+                    </a:lnB>
+                    <a:solidFill>
+                      <a:schemeClr val="bg1"/>
+                    </a:solidFill>
+                  </a:tcPr>
+                </a:tc>
+                <a:tc>
+                  <a:txBody>
+                    <a:bodyPr/>
+                    <a:lstStyle/>
+                    <a:p>
+                      <a:pPr algn="ctr" indent="0" marL="0">
+                        <a:buNone/>
+                      </a:pPr>
+                      <a:r>
+                        <a:rPr lang="en-US" sz="1250" dirty="0">
+                          <a:solidFill>
+                            <a:schemeClr val="tx1"/>
+                          </a:solidFill>
+                        </a:rPr>
+                        <a:t>10</a:t>
+                      </a:r>
+                      <a:endParaRPr lang="en-US" sz="1250" dirty="0"/>
+                    </a:p>
+                  </a:txBody>
+                  <a:tcPr marL="101600" marR="101600" marT="50800" marB="50800" anchor="ctr">
+                    <a:lnL w="9525" cap="flat" cmpd="sng" algn="ctr">
+                      <a:solidFill>
+                        <a:srgbClr val="EAF2F2"/>
+                      </a:solidFill>
+                      <a:prstDash val="solid"/>
+                      <a:round/>
+                      <a:headEnd type="none" w="med" len="med"/>
+                      <a:tailEnd type="none" w="med" len="med"/>
+                    </a:lnL>
+                    <a:lnR w="9525" cap="flat" cmpd="sng" algn="ctr">
+                      <a:solidFill>
+                        <a:srgbClr val="EAF2F2"/>
+                      </a:solidFill>
+                      <a:prstDash val="solid"/>
+                      <a:round/>
+                      <a:headEnd type="none" w="med" len="med"/>
+                      <a:tailEnd type="none" w="med" len="med"/>
+                    </a:lnR>
+                    <a:lnT w="9525" cap="flat" cmpd="sng" algn="ctr">
+                      <a:solidFill>
+                        <a:srgbClr val="EAF2F2"/>
+                      </a:solidFill>
+                      <a:prstDash val="solid"/>
+                      <a:round/>
+                      <a:headEnd type="none" w="med" len="med"/>
+                      <a:tailEnd type="none" w="med" len="med"/>
+                    </a:lnT>
+                    <a:lnB w="9525" cap="flat" cmpd="sng" algn="ctr">
+                      <a:solidFill>
+                        <a:srgbClr val="EAF2F2"/>
+                      </a:solidFill>
+                      <a:prstDash val="solid"/>
+                      <a:round/>
+                      <a:headEnd type="none" w="med" len="med"/>
+                      <a:tailEnd type="none" w="med" len="med"/>
+                    </a:lnB>
+                    <a:solidFill>
+                      <a:schemeClr val="bg1"/>
+                    </a:solidFill>
+                  </a:tcPr>
+                </a:tc>
+                <a:tc>
+                  <a:txBody>
+                    <a:bodyPr/>
+                    <a:lstStyle/>
+                    <a:p>
+                      <a:pPr algn="ctr" indent="0" marL="0">
+                        <a:buNone/>
+                      </a:pPr>
+                      <a:r>
+                        <a:rPr lang="en-US" sz="1250" dirty="0">
+                          <a:solidFill>
+                            <a:schemeClr val="tx1"/>
+                          </a:solidFill>
+                        </a:rPr>
+                        <a:t>1</a:t>
+                      </a:r>
+                      <a:endParaRPr lang="en-US" sz="1250" dirty="0"/>
+                    </a:p>
+                  </a:txBody>
+                  <a:tcPr marL="101600" marR="101600" marT="50800" marB="50800" anchor="ctr">
+                    <a:lnL w="9525" cap="flat" cmpd="sng" algn="ctr">
+                      <a:solidFill>
+                        <a:srgbClr val="EAF2F2"/>
+                      </a:solidFill>
+                      <a:prstDash val="solid"/>
+                      <a:round/>
+                      <a:headEnd type="none" w="med" len="med"/>
+                      <a:tailEnd type="none" w="med" len="med"/>
+                    </a:lnL>
+                    <a:lnR w="9525" cap="flat" cmpd="sng" algn="ctr">
+                      <a:solidFill>
+                        <a:srgbClr val="EAF2F2"/>
+                      </a:solidFill>
+                      <a:prstDash val="solid"/>
+                      <a:round/>
+                      <a:headEnd type="none" w="med" len="med"/>
+                      <a:tailEnd type="none" w="med" len="med"/>
+                    </a:lnR>
+                    <a:lnT w="9525" cap="flat" cmpd="sng" algn="ctr">
+                      <a:solidFill>
+                        <a:srgbClr val="EAF2F2"/>
+                      </a:solidFill>
+                      <a:prstDash val="solid"/>
+                      <a:round/>
+                      <a:headEnd type="none" w="med" len="med"/>
+                      <a:tailEnd type="none" w="med" len="med"/>
+                    </a:lnT>
+                    <a:lnB w="9525" cap="flat" cmpd="sng" algn="ctr">
+                      <a:solidFill>
+                        <a:srgbClr val="EAF2F2"/>
+                      </a:solidFill>
+                      <a:prstDash val="solid"/>
+                      <a:round/>
+                      <a:headEnd type="none" w="med" len="med"/>
+                      <a:tailEnd type="none" w="med" len="med"/>
+                    </a:lnB>
+                    <a:solidFill>
+                      <a:schemeClr val="bg1"/>
+                    </a:solidFill>
+                  </a:tcPr>
+                </a:tc>
+                <a:tc>
+                  <a:txBody>
+                    <a:bodyPr/>
+                    <a:lstStyle/>
+                    <a:p>
+                      <a:pPr algn="ctr" indent="0" marL="0">
+                        <a:buNone/>
+                      </a:pPr>
+                      <a:r>
+                        <a:rPr lang="en-US" sz="1250" dirty="0">
+                          <a:solidFill>
+                            <a:schemeClr val="tx1"/>
+                          </a:solidFill>
+                        </a:rPr>
+                        <a:t>2 min</a:t>
+                      </a:r>
+                      <a:endParaRPr lang="en-US" sz="1250" dirty="0"/>
+                    </a:p>
+                  </a:txBody>
+                  <a:tcPr marL="101600" marR="101600" marT="50800" marB="50800" anchor="ctr">
+                    <a:lnL w="9525" cap="flat" cmpd="sng" algn="ctr">
+                      <a:solidFill>
+                        <a:srgbClr val="EAF2F2"/>
+                      </a:solidFill>
+                      <a:prstDash val="solid"/>
+                      <a:round/>
+                      <a:headEnd type="none" w="med" len="med"/>
+                      <a:tailEnd type="none" w="med" len="med"/>
+                    </a:lnL>
+                    <a:lnR w="9525" cap="flat" cmpd="sng" algn="ctr">
+                      <a:solidFill>
+                        <a:srgbClr val="EAF2F2"/>
+                      </a:solidFill>
+                      <a:prstDash val="solid"/>
+                      <a:round/>
+                      <a:headEnd type="none" w="med" len="med"/>
+                      <a:tailEnd type="none" w="med" len="med"/>
+                    </a:lnR>
+                    <a:lnT w="9525" cap="flat" cmpd="sng" algn="ctr">
+                      <a:solidFill>
+                        <a:srgbClr val="EAF2F2"/>
+                      </a:solidFill>
+                      <a:prstDash val="solid"/>
+                      <a:round/>
+                      <a:headEnd type="none" w="med" len="med"/>
+                      <a:tailEnd type="none" w="med" len="med"/>
+                    </a:lnT>
+                    <a:lnB w="9525" cap="flat" cmpd="sng" algn="ctr">
+                      <a:solidFill>
+                        <a:srgbClr val="EAF2F2"/>
+                      </a:solidFill>
+                      <a:prstDash val="solid"/>
+                      <a:round/>
+                      <a:headEnd type="none" w="med" len="med"/>
+                      <a:tailEnd type="none" w="med" len="med"/>
+                    </a:lnB>
+                    <a:solidFill>
+                      <a:schemeClr val="bg1"/>
+                    </a:solidFill>
+                  </a:tcPr>
+                </a:tc>
+              </a:tr>
+              <a:tr h="310896">
+                <a:tc>
+                  <a:txBody>
+                    <a:bodyPr/>
+                    <a:lstStyle/>
+                    <a:p>
+                      <a:pPr indent="0" marL="0">
+                        <a:buNone/>
+                      </a:pPr>
+                      <a:r>
+                        <a:rPr lang="en-US" sz="1250" dirty="0">
+                          <a:solidFill>
+                            <a:schemeClr val="tx1"/>
+                          </a:solidFill>
+                        </a:rPr>
+                        <a:t>Re-check a reminder</a:t>
+                      </a:r>
+                      <a:endParaRPr lang="en-US" sz="1250" dirty="0"/>
+                    </a:p>
+                  </a:txBody>
+                  <a:tcPr marL="101600" marR="101600" marT="50800" marB="50800" anchor="ctr">
+                    <a:lnL w="9525" cap="flat" cmpd="sng" algn="ctr">
+                      <a:solidFill>
+                        <a:srgbClr val="EAF2F2"/>
+                      </a:solidFill>
+                      <a:prstDash val="solid"/>
+                      <a:round/>
+                      <a:headEnd type="none" w="med" len="med"/>
+                      <a:tailEnd type="none" w="med" len="med"/>
+                    </a:lnL>
+                    <a:lnR w="9525" cap="flat" cmpd="sng" algn="ctr">
+                      <a:solidFill>
+                        <a:srgbClr val="EAF2F2"/>
+                      </a:solidFill>
+                      <a:prstDash val="solid"/>
+                      <a:round/>
+                      <a:headEnd type="none" w="med" len="med"/>
+                      <a:tailEnd type="none" w="med" len="med"/>
+                    </a:lnR>
+                    <a:lnT w="9525" cap="flat" cmpd="sng" algn="ctr">
+                      <a:solidFill>
+                        <a:srgbClr val="EAF2F2"/>
+                      </a:solidFill>
+                      <a:prstDash val="solid"/>
+                      <a:round/>
+                      <a:headEnd type="none" w="med" len="med"/>
+                      <a:tailEnd type="none" w="med" len="med"/>
+                    </a:lnT>
+                    <a:lnB w="9525" cap="flat" cmpd="sng" algn="ctr">
+                      <a:solidFill>
+                        <a:srgbClr val="EAF2F2"/>
+                      </a:solidFill>
+                      <a:prstDash val="solid"/>
+                      <a:round/>
+                      <a:headEnd type="none" w="med" len="med"/>
+                      <a:tailEnd type="none" w="med" len="med"/>
+                    </a:lnB>
+                    <a:solidFill>
+                      <a:schemeClr val="bg2"/>
+                    </a:solidFill>
+                  </a:tcPr>
+                </a:tc>
+                <a:tc>
+                  <a:txBody>
+                    <a:bodyPr/>
+                    <a:lstStyle/>
+                    <a:p>
+                      <a:pPr algn="ctr" indent="0" marL="0">
+                        <a:buNone/>
+                      </a:pPr>
+                      <a:r>
+                        <a:rPr lang="en-US" sz="1250" dirty="0">
+                          <a:solidFill>
+                            <a:schemeClr val="tx1"/>
+                          </a:solidFill>
+                        </a:rPr>
+                        <a:t>10</a:t>
+                      </a:r>
+                      <a:endParaRPr lang="en-US" sz="1250" dirty="0"/>
+                    </a:p>
+                  </a:txBody>
+                  <a:tcPr marL="101600" marR="101600" marT="50800" marB="50800" anchor="ctr">
+                    <a:lnL w="9525" cap="flat" cmpd="sng" algn="ctr">
+                      <a:solidFill>
+                        <a:srgbClr val="EAF2F2"/>
+                      </a:solidFill>
+                      <a:prstDash val="solid"/>
+                      <a:round/>
+                      <a:headEnd type="none" w="med" len="med"/>
+                      <a:tailEnd type="none" w="med" len="med"/>
+                    </a:lnL>
+                    <a:lnR w="9525" cap="flat" cmpd="sng" algn="ctr">
+                      <a:solidFill>
+                        <a:srgbClr val="EAF2F2"/>
+                      </a:solidFill>
+                      <a:prstDash val="solid"/>
+                      <a:round/>
+                      <a:headEnd type="none" w="med" len="med"/>
+                      <a:tailEnd type="none" w="med" len="med"/>
+                    </a:lnR>
+                    <a:lnT w="9525" cap="flat" cmpd="sng" algn="ctr">
+                      <a:solidFill>
+                        <a:srgbClr val="EAF2F2"/>
+                      </a:solidFill>
+                      <a:prstDash val="solid"/>
+                      <a:round/>
+                      <a:headEnd type="none" w="med" len="med"/>
+                      <a:tailEnd type="none" w="med" len="med"/>
+                    </a:lnT>
+                    <a:lnB w="9525" cap="flat" cmpd="sng" algn="ctr">
+                      <a:solidFill>
+                        <a:srgbClr val="EAF2F2"/>
+                      </a:solidFill>
+                      <a:prstDash val="solid"/>
+                      <a:round/>
+                      <a:headEnd type="none" w="med" len="med"/>
+                      <a:tailEnd type="none" w="med" len="med"/>
+                    </a:lnB>
+                    <a:solidFill>
+                      <a:schemeClr val="bg2"/>
+                    </a:solidFill>
+                  </a:tcPr>
+                </a:tc>
+                <a:tc>
+                  <a:txBody>
+                    <a:bodyPr/>
+                    <a:lstStyle/>
+                    <a:p>
+                      <a:pPr algn="ctr" indent="0" marL="0">
+                        <a:buNone/>
+                      </a:pPr>
+                      <a:r>
+                        <a:rPr lang="en-US" sz="1250" dirty="0">
+                          <a:solidFill>
+                            <a:schemeClr val="tx1"/>
+                          </a:solidFill>
+                        </a:rPr>
+                        <a:t>1</a:t>
+                      </a:r>
+                      <a:endParaRPr lang="en-US" sz="1250" dirty="0"/>
+                    </a:p>
+                  </a:txBody>
+                  <a:tcPr marL="101600" marR="101600" marT="50800" marB="50800" anchor="ctr">
+                    <a:lnL w="9525" cap="flat" cmpd="sng" algn="ctr">
+                      <a:solidFill>
+                        <a:srgbClr val="EAF2F2"/>
+                      </a:solidFill>
+                      <a:prstDash val="solid"/>
+                      <a:round/>
+                      <a:headEnd type="none" w="med" len="med"/>
+                      <a:tailEnd type="none" w="med" len="med"/>
+                    </a:lnL>
+                    <a:lnR w="9525" cap="flat" cmpd="sng" algn="ctr">
+                      <a:solidFill>
+                        <a:srgbClr val="EAF2F2"/>
+                      </a:solidFill>
+                      <a:prstDash val="solid"/>
+                      <a:round/>
+                      <a:headEnd type="none" w="med" len="med"/>
+                      <a:tailEnd type="none" w="med" len="med"/>
+                    </a:lnR>
+                    <a:lnT w="9525" cap="flat" cmpd="sng" algn="ctr">
+                      <a:solidFill>
+                        <a:srgbClr val="EAF2F2"/>
+                      </a:solidFill>
+                      <a:prstDash val="solid"/>
+                      <a:round/>
+                      <a:headEnd type="none" w="med" len="med"/>
+                      <a:tailEnd type="none" w="med" len="med"/>
+                    </a:lnT>
+                    <a:lnB w="9525" cap="flat" cmpd="sng" algn="ctr">
+                      <a:solidFill>
+                        <a:srgbClr val="EAF2F2"/>
+                      </a:solidFill>
+                      <a:prstDash val="solid"/>
+                      <a:round/>
+                      <a:headEnd type="none" w="med" len="med"/>
+                      <a:tailEnd type="none" w="med" len="med"/>
+                    </a:lnB>
+                    <a:solidFill>
+                      <a:schemeClr val="bg2"/>
+                    </a:solidFill>
+                  </a:tcPr>
+                </a:tc>
+                <a:tc>
+                  <a:txBody>
+                    <a:bodyPr/>
+                    <a:lstStyle/>
+                    <a:p>
+                      <a:pPr algn="ctr" indent="0" marL="0">
+                        <a:buNone/>
+                      </a:pPr>
+                      <a:r>
+                        <a:rPr lang="en-US" sz="1250" dirty="0">
+                          <a:solidFill>
+                            <a:schemeClr val="tx1"/>
+                          </a:solidFill>
+                        </a:rPr>
+                        <a:t>0 min</a:t>
+                      </a:r>
+                      <a:endParaRPr lang="en-US" sz="1250" dirty="0"/>
+                    </a:p>
+                  </a:txBody>
+                  <a:tcPr marL="101600" marR="101600" marT="50800" marB="50800" anchor="ctr">
+                    <a:lnL w="9525" cap="flat" cmpd="sng" algn="ctr">
+                      <a:solidFill>
+                        <a:srgbClr val="EAF2F2"/>
+                      </a:solidFill>
+                      <a:prstDash val="solid"/>
+                      <a:round/>
+                      <a:headEnd type="none" w="med" len="med"/>
+                      <a:tailEnd type="none" w="med" len="med"/>
+                    </a:lnL>
+                    <a:lnR w="9525" cap="flat" cmpd="sng" algn="ctr">
+                      <a:solidFill>
+                        <a:srgbClr val="EAF2F2"/>
+                      </a:solidFill>
+                      <a:prstDash val="solid"/>
+                      <a:round/>
+                      <a:headEnd type="none" w="med" len="med"/>
+                      <a:tailEnd type="none" w="med" len="med"/>
+                    </a:lnR>
+                    <a:lnT w="9525" cap="flat" cmpd="sng" algn="ctr">
+                      <a:solidFill>
+                        <a:srgbClr val="EAF2F2"/>
+                      </a:solidFill>
+                      <a:prstDash val="solid"/>
+                      <a:round/>
+                      <a:headEnd type="none" w="med" len="med"/>
+                      <a:tailEnd type="none" w="med" len="med"/>
+                    </a:lnT>
+                    <a:lnB w="9525" cap="flat" cmpd="sng" algn="ctr">
+                      <a:solidFill>
+                        <a:srgbClr val="EAF2F2"/>
+                      </a:solidFill>
+                      <a:prstDash val="solid"/>
+                      <a:round/>
+                      <a:headEnd type="none" w="med" len="med"/>
+                      <a:tailEnd type="none" w="med" len="med"/>
+                    </a:lnB>
+                    <a:solidFill>
+                      <a:schemeClr val="bg2"/>
+                    </a:solidFill>
+                  </a:tcPr>
+                </a:tc>
+              </a:tr>
+              <a:tr h="310896">
+                <a:tc>
+                  <a:txBody>
+                    <a:bodyPr/>
+                    <a:lstStyle/>
+                    <a:p>
+                      <a:pPr indent="0" marL="0">
+                        <a:buNone/>
+                      </a:pPr>
+                      <a:r>
+                        <a:rPr lang="en-US" sz="1250" dirty="0">
+                          <a:solidFill>
+                            <a:schemeClr val="tx1"/>
+                          </a:solidFill>
+                        </a:rPr>
+                        <a:t>Weekly KPI report (share per day)</a:t>
+                      </a:r>
+                      <a:endParaRPr lang="en-US" sz="1250" dirty="0"/>
+                    </a:p>
+                  </a:txBody>
+                  <a:tcPr marL="101600" marR="101600" marT="50800" marB="50800" anchor="ctr">
+                    <a:lnL w="9525" cap="flat" cmpd="sng" algn="ctr">
+                      <a:solidFill>
+                        <a:srgbClr val="EAF2F2"/>
+                      </a:solidFill>
+                      <a:prstDash val="solid"/>
+                      <a:round/>
+                      <a:headEnd type="none" w="med" len="med"/>
+                      <a:tailEnd type="none" w="med" len="med"/>
+                    </a:lnL>
+                    <a:lnR w="9525" cap="flat" cmpd="sng" algn="ctr">
+                      <a:solidFill>
+                        <a:srgbClr val="EAF2F2"/>
+                      </a:solidFill>
+                      <a:prstDash val="solid"/>
+                      <a:round/>
+                      <a:headEnd type="none" w="med" len="med"/>
+                      <a:tailEnd type="none" w="med" len="med"/>
+                    </a:lnR>
+                    <a:lnT w="9525" cap="flat" cmpd="sng" algn="ctr">
+                      <a:solidFill>
+                        <a:srgbClr val="EAF2F2"/>
+                      </a:solidFill>
+                      <a:prstDash val="solid"/>
+                      <a:round/>
+                      <a:headEnd type="none" w="med" len="med"/>
+                      <a:tailEnd type="none" w="med" len="med"/>
+                    </a:lnT>
+                    <a:lnB w="9525" cap="flat" cmpd="sng" algn="ctr">
+                      <a:solidFill>
+                        <a:srgbClr val="EAF2F2"/>
+                      </a:solidFill>
+                      <a:prstDash val="solid"/>
+                      <a:round/>
+                      <a:headEnd type="none" w="med" len="med"/>
+                      <a:tailEnd type="none" w="med" len="med"/>
+                    </a:lnB>
+                    <a:solidFill>
+                      <a:schemeClr val="bg1"/>
+                    </a:solidFill>
+                  </a:tcPr>
+                </a:tc>
+                <a:tc>
+                  <a:txBody>
+                    <a:bodyPr/>
+                    <a:lstStyle/>
+                    <a:p>
+                      <a:pPr algn="ctr" indent="0" marL="0">
+                        <a:buNone/>
+                      </a:pPr>
+                      <a:r>
+                        <a:rPr lang="en-US" sz="1250" dirty="0">
+                          <a:solidFill>
+                            <a:schemeClr val="tx1"/>
+                          </a:solidFill>
+                        </a:rPr>
+                        <a:t>20</a:t>
+                      </a:r>
+                      <a:endParaRPr lang="en-US" sz="1250" dirty="0"/>
+                    </a:p>
+                  </a:txBody>
+                  <a:tcPr marL="101600" marR="101600" marT="50800" marB="50800" anchor="ctr">
+                    <a:lnL w="9525" cap="flat" cmpd="sng" algn="ctr">
+                      <a:solidFill>
+                        <a:srgbClr val="EAF2F2"/>
+                      </a:solidFill>
+                      <a:prstDash val="solid"/>
+                      <a:round/>
+                      <a:headEnd type="none" w="med" len="med"/>
+                      <a:tailEnd type="none" w="med" len="med"/>
+                    </a:lnL>
+                    <a:lnR w="9525" cap="flat" cmpd="sng" algn="ctr">
+                      <a:solidFill>
+                        <a:srgbClr val="EAF2F2"/>
+                      </a:solidFill>
+                      <a:prstDash val="solid"/>
+                      <a:round/>
+                      <a:headEnd type="none" w="med" len="med"/>
+                      <a:tailEnd type="none" w="med" len="med"/>
+                    </a:lnR>
+                    <a:lnT w="9525" cap="flat" cmpd="sng" algn="ctr">
+                      <a:solidFill>
+                        <a:srgbClr val="EAF2F2"/>
+                      </a:solidFill>
+                      <a:prstDash val="solid"/>
+                      <a:round/>
+                      <a:headEnd type="none" w="med" len="med"/>
+                      <a:tailEnd type="none" w="med" len="med"/>
+                    </a:lnT>
+                    <a:lnB w="9525" cap="flat" cmpd="sng" algn="ctr">
+                      <a:solidFill>
+                        <a:srgbClr val="EAF2F2"/>
+                      </a:solidFill>
+                      <a:prstDash val="solid"/>
+                      <a:round/>
+                      <a:headEnd type="none" w="med" len="med"/>
+                      <a:tailEnd type="none" w="med" len="med"/>
+                    </a:lnB>
+                    <a:solidFill>
+                      <a:schemeClr val="bg1"/>
+                    </a:solidFill>
+                  </a:tcPr>
+                </a:tc>
+                <a:tc>
+                  <a:txBody>
+                    <a:bodyPr/>
+                    <a:lstStyle/>
+                    <a:p>
+                      <a:pPr algn="ctr" indent="0" marL="0">
+                        <a:buNone/>
+                      </a:pPr>
+                      <a:r>
+                        <a:rPr lang="en-US" sz="1250" dirty="0">
+                          <a:solidFill>
+                            <a:schemeClr val="tx1"/>
+                          </a:solidFill>
+                        </a:rPr>
+                        <a:t>1</a:t>
+                      </a:r>
+                      <a:endParaRPr lang="en-US" sz="1250" dirty="0"/>
+                    </a:p>
+                  </a:txBody>
+                  <a:tcPr marL="101600" marR="101600" marT="50800" marB="50800" anchor="ctr">
+                    <a:lnL w="9525" cap="flat" cmpd="sng" algn="ctr">
+                      <a:solidFill>
+                        <a:srgbClr val="EAF2F2"/>
+                      </a:solidFill>
+                      <a:prstDash val="solid"/>
+                      <a:round/>
+                      <a:headEnd type="none" w="med" len="med"/>
+                      <a:tailEnd type="none" w="med" len="med"/>
+                    </a:lnL>
+                    <a:lnR w="9525" cap="flat" cmpd="sng" algn="ctr">
+                      <a:solidFill>
+                        <a:srgbClr val="EAF2F2"/>
+                      </a:solidFill>
+                      <a:prstDash val="solid"/>
+                      <a:round/>
+                      <a:headEnd type="none" w="med" len="med"/>
+                      <a:tailEnd type="none" w="med" len="med"/>
+                    </a:lnR>
+                    <a:lnT w="9525" cap="flat" cmpd="sng" algn="ctr">
+                      <a:solidFill>
+                        <a:srgbClr val="EAF2F2"/>
+                      </a:solidFill>
+                      <a:prstDash val="solid"/>
+                      <a:round/>
+                      <a:headEnd type="none" w="med" len="med"/>
+                      <a:tailEnd type="none" w="med" len="med"/>
+                    </a:lnT>
+                    <a:lnB w="9525" cap="flat" cmpd="sng" algn="ctr">
+                      <a:solidFill>
+                        <a:srgbClr val="EAF2F2"/>
+                      </a:solidFill>
+                      <a:prstDash val="solid"/>
+                      <a:round/>
+                      <a:headEnd type="none" w="med" len="med"/>
+                      <a:tailEnd type="none" w="med" len="med"/>
+                    </a:lnB>
+                    <a:solidFill>
+                      <a:schemeClr val="bg1"/>
+                    </a:solidFill>
+                  </a:tcPr>
+                </a:tc>
+                <a:tc>
+                  <a:txBody>
+                    <a:bodyPr/>
+                    <a:lstStyle/>
+                    <a:p>
+                      <a:pPr algn="ctr" indent="0" marL="0">
+                        <a:buNone/>
+                      </a:pPr>
+                      <a:r>
+                        <a:rPr lang="en-US" sz="1250" dirty="0">
+                          <a:solidFill>
+                            <a:schemeClr val="tx1"/>
+                          </a:solidFill>
+                        </a:rPr>
+                        <a:t>5 min</a:t>
+                      </a:r>
+                      <a:endParaRPr lang="en-US" sz="1250" dirty="0"/>
+                    </a:p>
+                  </a:txBody>
+                  <a:tcPr marL="101600" marR="101600" marT="50800" marB="50800" anchor="ctr">
+                    <a:lnL w="9525" cap="flat" cmpd="sng" algn="ctr">
+                      <a:solidFill>
+                        <a:srgbClr val="EAF2F2"/>
+                      </a:solidFill>
+                      <a:prstDash val="solid"/>
+                      <a:round/>
+                      <a:headEnd type="none" w="med" len="med"/>
+                      <a:tailEnd type="none" w="med" len="med"/>
+                    </a:lnL>
+                    <a:lnR w="9525" cap="flat" cmpd="sng" algn="ctr">
+                      <a:solidFill>
+                        <a:srgbClr val="EAF2F2"/>
+                      </a:solidFill>
+                      <a:prstDash val="solid"/>
+                      <a:round/>
+                      <a:headEnd type="none" w="med" len="med"/>
+                      <a:tailEnd type="none" w="med" len="med"/>
+                    </a:lnR>
+                    <a:lnT w="9525" cap="flat" cmpd="sng" algn="ctr">
+                      <a:solidFill>
+                        <a:srgbClr val="EAF2F2"/>
+                      </a:solidFill>
+                      <a:prstDash val="solid"/>
+                      <a:round/>
+                      <a:headEnd type="none" w="med" len="med"/>
+                      <a:tailEnd type="none" w="med" len="med"/>
+                    </a:lnT>
+                    <a:lnB w="9525" cap="flat" cmpd="sng" algn="ctr">
+                      <a:solidFill>
+                        <a:srgbClr val="EAF2F2"/>
+                      </a:solidFill>
+                      <a:prstDash val="solid"/>
+                      <a:round/>
+                      <a:headEnd type="none" w="med" len="med"/>
+                      <a:tailEnd type="none" w="med" len="med"/>
+                    </a:lnB>
+                    <a:solidFill>
+                      <a:schemeClr val="bg1"/>
+                    </a:solidFill>
+                  </a:tcPr>
+                </a:tc>
+              </a:tr>
+            </a:tbl>
+          </a:graphicData>
+        </a:graphic>
+      </p:graphicFrame>
+      <p:sp>
+        <p:nvSpPr>
+          <p:cNvPr id="6" name="Note"/>
+          <p:cNvSpPr txBox="1"/>
+          <p:nvPr/>
+        </p:nvSpPr>
+        <p:spPr>
+          <a:xfrm>
+            <a:off x="548640" y="4251960"/>
+            <a:ext cx="6583680" cy="685800"/>
+          </a:xfrm>
+          <a:prstGeom prst="rect">
+            <a:avLst/>
+          </a:prstGeom>
+          <a:noFill/>
+          <a:ln/>
+        </p:spPr>
+        <p:txBody>
+          <a:bodyPr wrap="square" lIns="0" tIns="0" rIns="0" bIns="0" rtlCol="0" anchor="t"/>
+          <a:lstStyle/>
+          <a:p>
+            <a:pPr algn="l" indent="0" marL="0">
+              <a:buNone/>
+            </a:pPr>
+            <a:r>
+              <a:rPr lang="en-US" sz="1200" dirty="0">
+                <a:solidFill>
+                  <a:schemeClr val="tx1"/>
+                </a:solidFill>
+              </a:rPr>
+              <a:t>Each time is a range (low, likely, high), drawn 10,000 times. Result: 73 hours a month today, 11 with ThreadPilot, so 62 saved (51 to 75), at S$24.6 an hour (planner S$48k a year + CPF).</a:t>
+            </a:r>
+            <a:endParaRPr lang="en-US" sz="1200" dirty="0"/>
+          </a:p>
+        </p:txBody>
+      </p:sp>
+      <p:sp>
+        <p:nvSpPr>
+          <p:cNvPr id="7" name="Label"/>
+          <p:cNvSpPr txBox="1"/>
+          <p:nvPr/>
+        </p:nvSpPr>
+        <p:spPr>
+          <a:xfrm>
+            <a:off x="7452360" y="1234440"/>
+            <a:ext cx="4187952" cy="365760"/>
+          </a:xfrm>
+          <a:prstGeom prst="rect">
+            <a:avLst/>
+          </a:prstGeom>
+          <a:noFill/>
+          <a:ln/>
+        </p:spPr>
+        <p:txBody>
+          <a:bodyPr wrap="square" lIns="0" tIns="0" rIns="0" bIns="0" rtlCol="0" anchor="ctr"/>
+          <a:lstStyle/>
+          <a:p>
+            <a:pPr algn="l" indent="0" marL="0">
+              <a:buNone/>
+            </a:pPr>
+            <a:r>
+              <a:rPr lang="en-US" sz="1500" b="1" dirty="0">
+                <a:solidFill>
+                  <a:schemeClr val="tx2"/>
+                </a:solidFill>
+              </a:rPr>
+              <a:t>2. Lateness avoided (simulated)</a:t>
+            </a:r>
+            <a:endParaRPr lang="en-US" sz="1500" dirty="0"/>
+          </a:p>
+        </p:txBody>
+      </p:sp>
+      <p:sp>
+        <p:nvSpPr>
+          <p:cNvPr id="8" name="Note"/>
+          <p:cNvSpPr txBox="1"/>
+          <p:nvPr/>
+        </p:nvSpPr>
+        <p:spPr>
+          <a:xfrm>
+            <a:off x="7452360" y="1645920"/>
+            <a:ext cx="4187952" cy="1417320"/>
+          </a:xfrm>
+          <a:prstGeom prst="rect">
+            <a:avLst/>
+          </a:prstGeom>
+          <a:noFill/>
+          <a:ln/>
+        </p:spPr>
+        <p:txBody>
+          <a:bodyPr wrap="square" lIns="0" tIns="0" rIns="0" bIns="0" rtlCol="0" anchor="t"/>
+          <a:lstStyle/>
+          <a:p>
+            <a:pPr algn="l" indent="0" marL="0">
+              <a:buNone/>
+            </a:pPr>
+            <a:r>
+              <a:rPr lang="en-US" sz="1200" dirty="0">
+                <a:solidFill>
+                  <a:schemeClr val="tx1"/>
+                </a:solidFill>
+              </a:rPr>
+              <a:t>Same simulated factory, same random problems, run twice: noticed by a weekly check vs by the 07:00 briefing. Over about 88 orders, total lateness fell by 30.5 working days every two months (95%: 18 to 43). Priced at 1% of the order a day late (half of URBN's vendor rate) on an average order of US$5,515: S$72 per order-day.</a:t>
+            </a:r>
+            <a:endParaRPr lang="en-US" sz="1200" dirty="0"/>
+          </a:p>
+        </p:txBody>
+      </p:sp>
+      <p:graphicFrame>
+        <p:nvGraphicFramePr>
+          <p:cNvPr id="31" name="Money table"/>
+          <p:cNvGraphicFramePr>
+            <a:graphicFrameLocks noGrp="1"/>
+          </p:cNvGraphicFramePr>
+          <p:nvPr>
+            <p:extLst>
+              <p:ext uri="{D42A27DB-BD31-4B8C-83A1-F6EECF244321}">
+                <p14:modId xmlns:p14="http://schemas.microsoft.com/office/powerpoint/2010/main" val="1579011935"/>
+              </p:ext>
+            </p:extLst>
+          </p:nvPr>
+        </p:nvGraphicFramePr>
+        <p:xfrm>
+          <a:off x="7452360" y="3154680"/>
+          <a:ext cx="4187952" cy="914400"/>
+        </p:xfrm>
+        <a:graphic>
+          <a:graphicData uri="http://schemas.openxmlformats.org/drawingml/2006/table">
+            <a:tbl>
+              <a:tblPr/>
+              <a:tblGrid>
+                <a:gridCol w="2999232"/>
+                <a:gridCol w="1188720"/>
+              </a:tblGrid>
+              <a:tr h="329184">
+                <a:tc>
+                  <a:txBody>
+                    <a:bodyPr/>
+                    <a:lstStyle/>
+                    <a:p>
+                      <a:pPr algn="l" indent="0" marL="0">
+                        <a:buNone/>
+                      </a:pPr>
+                      <a:r>
+                        <a:rPr lang="en-US" sz="1300" b="1" dirty="0">
+                          <a:solidFill>
+                            <a:schemeClr val="bg1"/>
+                          </a:solidFill>
+                        </a:rPr>
+                        <a:t>A year, likely case</a:t>
+                      </a:r>
+                      <a:endParaRPr lang="en-US" sz="1300" dirty="0"/>
+                    </a:p>
+                  </a:txBody>
+                  <a:tcPr marL="101600" marR="101600" marT="50800" marB="50800" anchor="ctr">
+                    <a:lnL w="9525" cap="flat" cmpd="sng" algn="ctr">
+                      <a:solidFill>
+                        <a:srgbClr val="EAF2F2"/>
+                      </a:solidFill>
+                      <a:prstDash val="solid"/>
+                      <a:round/>
+                      <a:headEnd type="none" w="med" len="med"/>
+                      <a:tailEnd type="none" w="med" len="med"/>
+                    </a:lnL>
+                    <a:lnR w="9525" cap="flat" cmpd="sng" algn="ctr">
+                      <a:solidFill>
+                        <a:srgbClr val="EAF2F2"/>
+                      </a:solidFill>
+                      <a:prstDash val="solid"/>
+                      <a:round/>
+                      <a:headEnd type="none" w="med" len="med"/>
+                      <a:tailEnd type="none" w="med" len="med"/>
+                    </a:lnR>
+                    <a:lnT w="9525" cap="flat" cmpd="sng" algn="ctr">
+                      <a:solidFill>
+                        <a:srgbClr val="EAF2F2"/>
+                      </a:solidFill>
+                      <a:prstDash val="solid"/>
+                      <a:round/>
+                      <a:headEnd type="none" w="med" len="med"/>
+                      <a:tailEnd type="none" w="med" len="med"/>
+                    </a:lnT>
+                    <a:lnB w="9525" cap="flat" cmpd="sng" algn="ctr">
+                      <a:solidFill>
+                        <a:srgbClr val="EAF2F2"/>
+                      </a:solidFill>
+                      <a:prstDash val="solid"/>
+                      <a:round/>
+                      <a:headEnd type="none" w="med" len="med"/>
+                      <a:tailEnd type="none" w="med" len="med"/>
+                    </a:lnB>
+                    <a:solidFill>
+                      <a:schemeClr val="tx2"/>
+                    </a:solidFill>
+                  </a:tcPr>
+                </a:tc>
+                <a:tc>
+                  <a:txBody>
+                    <a:bodyPr/>
+                    <a:lstStyle/>
+                    <a:p>
+                      <a:pPr algn="ctr" indent="0" marL="0">
+                        <a:buNone/>
+                      </a:pPr>
+                      <a:r>
+                        <a:rPr lang="en-US" sz="1300" b="1" dirty="0">
+                          <a:solidFill>
+                            <a:schemeClr val="bg1"/>
+                          </a:solidFill>
+                        </a:rPr>
+                        <a:t>SGD</a:t>
+                      </a:r>
+                      <a:endParaRPr lang="en-US" sz="1300" dirty="0"/>
+                    </a:p>
+                  </a:txBody>
+                  <a:tcPr marL="101600" marR="101600" marT="50800" marB="50800" anchor="ctr">
+                    <a:lnL w="9525" cap="flat" cmpd="sng" algn="ctr">
+                      <a:solidFill>
+                        <a:srgbClr val="EAF2F2"/>
+                      </a:solidFill>
+                      <a:prstDash val="solid"/>
+                      <a:round/>
+                      <a:headEnd type="none" w="med" len="med"/>
+                      <a:tailEnd type="none" w="med" len="med"/>
+                    </a:lnL>
+                    <a:lnR w="9525" cap="flat" cmpd="sng" algn="ctr">
+                      <a:solidFill>
+                        <a:srgbClr val="EAF2F2"/>
+                      </a:solidFill>
+                      <a:prstDash val="solid"/>
+                      <a:round/>
+                      <a:headEnd type="none" w="med" len="med"/>
+                      <a:tailEnd type="none" w="med" len="med"/>
+                    </a:lnR>
+                    <a:lnT w="9525" cap="flat" cmpd="sng" algn="ctr">
+                      <a:solidFill>
+                        <a:srgbClr val="EAF2F2"/>
+                      </a:solidFill>
+                      <a:prstDash val="solid"/>
+                      <a:round/>
+                      <a:headEnd type="none" w="med" len="med"/>
+                      <a:tailEnd type="none" w="med" len="med"/>
+                    </a:lnT>
+                    <a:lnB w="9525" cap="flat" cmpd="sng" algn="ctr">
+                      <a:solidFill>
+                        <a:srgbClr val="EAF2F2"/>
+                      </a:solidFill>
+                      <a:prstDash val="solid"/>
+                      <a:round/>
+                      <a:headEnd type="none" w="med" len="med"/>
+                      <a:tailEnd type="none" w="med" len="med"/>
+                    </a:lnB>
+                    <a:solidFill>
+                      <a:schemeClr val="tx2"/>
+                    </a:solidFill>
+                  </a:tcPr>
+                </a:tc>
+              </a:tr>
+              <a:tr h="329184">
+                <a:tc>
+                  <a:txBody>
+                    <a:bodyPr/>
+                    <a:lstStyle/>
+                    <a:p>
+                      <a:pPr indent="0" marL="0">
+                        <a:buNone/>
+                      </a:pPr>
+                      <a:r>
+                        <a:rPr lang="en-US" sz="1250" dirty="0">
+                          <a:solidFill>
+                            <a:schemeClr val="tx1"/>
+                          </a:solidFill>
+                        </a:rPr>
+                        <a:t>Planner time freed</a:t>
+                      </a:r>
+                      <a:endParaRPr lang="en-US" sz="1250" dirty="0"/>
+                    </a:p>
+                  </a:txBody>
+                  <a:tcPr marL="101600" marR="101600" marT="50800" marB="50800" anchor="ctr">
+                    <a:lnL w="9525" cap="flat" cmpd="sng" algn="ctr">
+                      <a:solidFill>
+                        <a:srgbClr val="EAF2F2"/>
+                      </a:solidFill>
+                      <a:prstDash val="solid"/>
+                      <a:round/>
+                      <a:headEnd type="none" w="med" len="med"/>
+                      <a:tailEnd type="none" w="med" len="med"/>
+                    </a:lnL>
+                    <a:lnR w="9525" cap="flat" cmpd="sng" algn="ctr">
+                      <a:solidFill>
+                        <a:srgbClr val="EAF2F2"/>
+                      </a:solidFill>
+                      <a:prstDash val="solid"/>
+                      <a:round/>
+                      <a:headEnd type="none" w="med" len="med"/>
+                      <a:tailEnd type="none" w="med" len="med"/>
+                    </a:lnR>
+                    <a:lnT w="9525" cap="flat" cmpd="sng" algn="ctr">
+                      <a:solidFill>
+                        <a:srgbClr val="EAF2F2"/>
+                      </a:solidFill>
+                      <a:prstDash val="solid"/>
+                      <a:round/>
+                      <a:headEnd type="none" w="med" len="med"/>
+                      <a:tailEnd type="none" w="med" len="med"/>
+                    </a:lnT>
+                    <a:lnB w="9525" cap="flat" cmpd="sng" algn="ctr">
+                      <a:solidFill>
+                        <a:srgbClr val="EAF2F2"/>
+                      </a:solidFill>
+                      <a:prstDash val="solid"/>
+                      <a:round/>
+                      <a:headEnd type="none" w="med" len="med"/>
+                      <a:tailEnd type="none" w="med" len="med"/>
+                    </a:lnB>
+                    <a:solidFill>
+                      <a:schemeClr val="bg1"/>
+                    </a:solidFill>
+                  </a:tcPr>
+                </a:tc>
+                <a:tc>
+                  <a:txBody>
+                    <a:bodyPr/>
+                    <a:lstStyle/>
+                    <a:p>
+                      <a:pPr algn="ctr" indent="0" marL="0">
+                        <a:buNone/>
+                      </a:pPr>
+                      <a:r>
+                        <a:rPr lang="en-US" sz="1250" dirty="0">
+                          <a:solidFill>
+                            <a:schemeClr val="tx1"/>
+                          </a:solidFill>
+                        </a:rPr>
+                        <a:t>S$18.4k</a:t>
+                      </a:r>
+                      <a:endParaRPr lang="en-US" sz="1250" dirty="0"/>
+                    </a:p>
+                  </a:txBody>
+                  <a:tcPr marL="101600" marR="101600" marT="50800" marB="50800" anchor="ctr">
+                    <a:lnL w="9525" cap="flat" cmpd="sng" algn="ctr">
+                      <a:solidFill>
+                        <a:srgbClr val="EAF2F2"/>
+                      </a:solidFill>
+                      <a:prstDash val="solid"/>
+                      <a:round/>
+                      <a:headEnd type="none" w="med" len="med"/>
+                      <a:tailEnd type="none" w="med" len="med"/>
+                    </a:lnL>
+                    <a:lnR w="9525" cap="flat" cmpd="sng" algn="ctr">
+                      <a:solidFill>
+                        <a:srgbClr val="EAF2F2"/>
+                      </a:solidFill>
+                      <a:prstDash val="solid"/>
+                      <a:round/>
+                      <a:headEnd type="none" w="med" len="med"/>
+                      <a:tailEnd type="none" w="med" len="med"/>
+                    </a:lnR>
+                    <a:lnT w="9525" cap="flat" cmpd="sng" algn="ctr">
+                      <a:solidFill>
+                        <a:srgbClr val="EAF2F2"/>
+                      </a:solidFill>
+                      <a:prstDash val="solid"/>
+                      <a:round/>
+                      <a:headEnd type="none" w="med" len="med"/>
+                      <a:tailEnd type="none" w="med" len="med"/>
+                    </a:lnT>
+                    <a:lnB w="9525" cap="flat" cmpd="sng" algn="ctr">
+                      <a:solidFill>
+                        <a:srgbClr val="EAF2F2"/>
+                      </a:solidFill>
+                      <a:prstDash val="solid"/>
+                      <a:round/>
+                      <a:headEnd type="none" w="med" len="med"/>
+                      <a:tailEnd type="none" w="med" len="med"/>
+                    </a:lnB>
+                    <a:solidFill>
+                      <a:schemeClr val="bg1"/>
+                    </a:solidFill>
+                  </a:tcPr>
+                </a:tc>
+              </a:tr>
+              <a:tr h="329184">
+                <a:tc>
+                  <a:txBody>
+                    <a:bodyPr/>
+                    <a:lstStyle/>
+                    <a:p>
+                      <a:pPr indent="0" marL="0">
+                        <a:buNone/>
+                      </a:pPr>
+                      <a:r>
+                        <a:rPr lang="en-US" sz="1250" dirty="0">
+                          <a:solidFill>
+                            <a:schemeClr val="tx1"/>
+                          </a:solidFill>
+                        </a:rPr>
+                        <a:t>Late penalties avoided</a:t>
+                      </a:r>
+                      <a:endParaRPr lang="en-US" sz="1250" dirty="0"/>
+                    </a:p>
+                  </a:txBody>
+                  <a:tcPr marL="101600" marR="101600" marT="50800" marB="50800" anchor="ctr">
+                    <a:lnL w="9525" cap="flat" cmpd="sng" algn="ctr">
+                      <a:solidFill>
+                        <a:srgbClr val="EAF2F2"/>
+                      </a:solidFill>
+                      <a:prstDash val="solid"/>
+                      <a:round/>
+                      <a:headEnd type="none" w="med" len="med"/>
+                      <a:tailEnd type="none" w="med" len="med"/>
+                    </a:lnL>
+                    <a:lnR w="9525" cap="flat" cmpd="sng" algn="ctr">
+                      <a:solidFill>
+                        <a:srgbClr val="EAF2F2"/>
+                      </a:solidFill>
+                      <a:prstDash val="solid"/>
+                      <a:round/>
+                      <a:headEnd type="none" w="med" len="med"/>
+                      <a:tailEnd type="none" w="med" len="med"/>
+                    </a:lnR>
+                    <a:lnT w="9525" cap="flat" cmpd="sng" algn="ctr">
+                      <a:solidFill>
+                        <a:srgbClr val="EAF2F2"/>
+                      </a:solidFill>
+                      <a:prstDash val="solid"/>
+                      <a:round/>
+                      <a:headEnd type="none" w="med" len="med"/>
+                      <a:tailEnd type="none" w="med" len="med"/>
+                    </a:lnT>
+                    <a:lnB w="9525" cap="flat" cmpd="sng" algn="ctr">
+                      <a:solidFill>
+                        <a:srgbClr val="EAF2F2"/>
+                      </a:solidFill>
+                      <a:prstDash val="solid"/>
+                      <a:round/>
+                      <a:headEnd type="none" w="med" len="med"/>
+                      <a:tailEnd type="none" w="med" len="med"/>
+                    </a:lnB>
+                    <a:solidFill>
+                      <a:schemeClr val="bg2"/>
+                    </a:solidFill>
+                  </a:tcPr>
+                </a:tc>
+                <a:tc>
+                  <a:txBody>
+                    <a:bodyPr/>
+                    <a:lstStyle/>
+                    <a:p>
+                      <a:pPr algn="ctr" indent="0" marL="0">
+                        <a:buNone/>
+                      </a:pPr>
+                      <a:r>
+                        <a:rPr lang="en-US" sz="1250" dirty="0">
+                          <a:solidFill>
+                            <a:schemeClr val="tx1"/>
+                          </a:solidFill>
+                        </a:rPr>
+                        <a:t>S$13.1k</a:t>
+                      </a:r>
+                      <a:endParaRPr lang="en-US" sz="1250" dirty="0"/>
+                    </a:p>
+                  </a:txBody>
+                  <a:tcPr marL="101600" marR="101600" marT="50800" marB="50800" anchor="ctr">
+                    <a:lnL w="9525" cap="flat" cmpd="sng" algn="ctr">
+                      <a:solidFill>
+                        <a:srgbClr val="EAF2F2"/>
+                      </a:solidFill>
+                      <a:prstDash val="solid"/>
+                      <a:round/>
+                      <a:headEnd type="none" w="med" len="med"/>
+                      <a:tailEnd type="none" w="med" len="med"/>
+                    </a:lnL>
+                    <a:lnR w="9525" cap="flat" cmpd="sng" algn="ctr">
+                      <a:solidFill>
+                        <a:srgbClr val="EAF2F2"/>
+                      </a:solidFill>
+                      <a:prstDash val="solid"/>
+                      <a:round/>
+                      <a:headEnd type="none" w="med" len="med"/>
+                      <a:tailEnd type="none" w="med" len="med"/>
+                    </a:lnR>
+                    <a:lnT w="9525" cap="flat" cmpd="sng" algn="ctr">
+                      <a:solidFill>
+                        <a:srgbClr val="EAF2F2"/>
+                      </a:solidFill>
+                      <a:prstDash val="solid"/>
+                      <a:round/>
+                      <a:headEnd type="none" w="med" len="med"/>
+                      <a:tailEnd type="none" w="med" len="med"/>
+                    </a:lnT>
+                    <a:lnB w="9525" cap="flat" cmpd="sng" algn="ctr">
+                      <a:solidFill>
+                        <a:srgbClr val="EAF2F2"/>
+                      </a:solidFill>
+                      <a:prstDash val="solid"/>
+                      <a:round/>
+                      <a:headEnd type="none" w="med" len="med"/>
+                      <a:tailEnd type="none" w="med" len="med"/>
+                    </a:lnB>
+                    <a:solidFill>
+                      <a:schemeClr val="bg2"/>
+                    </a:solidFill>
+                  </a:tcPr>
+                </a:tc>
+              </a:tr>
+              <a:tr h="329184">
+                <a:tc>
+                  <a:txBody>
+                    <a:bodyPr/>
+                    <a:lstStyle/>
+                    <a:p>
+                      <a:pPr indent="0" marL="0">
+                        <a:buNone/>
+                      </a:pPr>
+                      <a:r>
+                        <a:rPr lang="en-US" sz="1250" dirty="0">
+                          <a:solidFill>
+                            <a:schemeClr val="tx1"/>
+                          </a:solidFill>
+                        </a:rPr>
+                        <a:t>Running ThreadPilot</a:t>
+                      </a:r>
+                      <a:endParaRPr lang="en-US" sz="1250" dirty="0"/>
+                    </a:p>
+                  </a:txBody>
+                  <a:tcPr marL="101600" marR="101600" marT="50800" marB="50800" anchor="ctr">
+                    <a:lnL w="9525" cap="flat" cmpd="sng" algn="ctr">
+                      <a:solidFill>
+                        <a:srgbClr val="EAF2F2"/>
+                      </a:solidFill>
+                      <a:prstDash val="solid"/>
+                      <a:round/>
+                      <a:headEnd type="none" w="med" len="med"/>
+                      <a:tailEnd type="none" w="med" len="med"/>
+                    </a:lnL>
+                    <a:lnR w="9525" cap="flat" cmpd="sng" algn="ctr">
+                      <a:solidFill>
+                        <a:srgbClr val="EAF2F2"/>
+                      </a:solidFill>
+                      <a:prstDash val="solid"/>
+                      <a:round/>
+                      <a:headEnd type="none" w="med" len="med"/>
+                      <a:tailEnd type="none" w="med" len="med"/>
+                    </a:lnR>
+                    <a:lnT w="9525" cap="flat" cmpd="sng" algn="ctr">
+                      <a:solidFill>
+                        <a:srgbClr val="EAF2F2"/>
+                      </a:solidFill>
+                      <a:prstDash val="solid"/>
+                      <a:round/>
+                      <a:headEnd type="none" w="med" len="med"/>
+                      <a:tailEnd type="none" w="med" len="med"/>
+                    </a:lnT>
+                    <a:lnB w="9525" cap="flat" cmpd="sng" algn="ctr">
+                      <a:solidFill>
+                        <a:srgbClr val="EAF2F2"/>
+                      </a:solidFill>
+                      <a:prstDash val="solid"/>
+                      <a:round/>
+                      <a:headEnd type="none" w="med" len="med"/>
+                      <a:tailEnd type="none" w="med" len="med"/>
+                    </a:lnB>
+                    <a:solidFill>
+                      <a:schemeClr val="bg1"/>
+                    </a:solidFill>
+                  </a:tcPr>
+                </a:tc>
+                <a:tc>
+                  <a:txBody>
+                    <a:bodyPr/>
+                    <a:lstStyle/>
+                    <a:p>
+                      <a:pPr algn="ctr" indent="0" marL="0">
+                        <a:buNone/>
+                      </a:pPr>
+                      <a:r>
+                        <a:rPr lang="en-US" sz="1250" dirty="0">
+                          <a:solidFill>
+                            <a:schemeClr val="tx1"/>
+                          </a:solidFill>
+                        </a:rPr>
+                        <a:t>−S$1.9k</a:t>
+                      </a:r>
+                      <a:endParaRPr lang="en-US" sz="1250" dirty="0"/>
+                    </a:p>
+                  </a:txBody>
+                  <a:tcPr marL="101600" marR="101600" marT="50800" marB="50800" anchor="ctr">
+                    <a:lnL w="9525" cap="flat" cmpd="sng" algn="ctr">
+                      <a:solidFill>
+                        <a:srgbClr val="EAF2F2"/>
+                      </a:solidFill>
+                      <a:prstDash val="solid"/>
+                      <a:round/>
+                      <a:headEnd type="none" w="med" len="med"/>
+                      <a:tailEnd type="none" w="med" len="med"/>
+                    </a:lnL>
+                    <a:lnR w="9525" cap="flat" cmpd="sng" algn="ctr">
+                      <a:solidFill>
+                        <a:srgbClr val="EAF2F2"/>
+                      </a:solidFill>
+                      <a:prstDash val="solid"/>
+                      <a:round/>
+                      <a:headEnd type="none" w="med" len="med"/>
+                      <a:tailEnd type="none" w="med" len="med"/>
+                    </a:lnR>
+                    <a:lnT w="9525" cap="flat" cmpd="sng" algn="ctr">
+                      <a:solidFill>
+                        <a:srgbClr val="EAF2F2"/>
+                      </a:solidFill>
+                      <a:prstDash val="solid"/>
+                      <a:round/>
+                      <a:headEnd type="none" w="med" len="med"/>
+                      <a:tailEnd type="none" w="med" len="med"/>
+                    </a:lnT>
+                    <a:lnB w="9525" cap="flat" cmpd="sng" algn="ctr">
+                      <a:solidFill>
+                        <a:srgbClr val="EAF2F2"/>
+                      </a:solidFill>
+                      <a:prstDash val="solid"/>
+                      <a:round/>
+                      <a:headEnd type="none" w="med" len="med"/>
+                      <a:tailEnd type="none" w="med" len="med"/>
+                    </a:lnB>
+                    <a:solidFill>
+                      <a:schemeClr val="bg1"/>
+                    </a:solidFill>
+                  </a:tcPr>
+                </a:tc>
+              </a:tr>
+              <a:tr h="329184">
+                <a:tc>
+                  <a:txBody>
+                    <a:bodyPr/>
+                    <a:lstStyle/>
+                    <a:p>
+                      <a:pPr indent="0" marL="0">
+                        <a:buNone/>
+                      </a:pPr>
+                      <a:r>
+                        <a:rPr lang="en-US" sz="1250" b="1" dirty="0">
+                          <a:solidFill>
+                            <a:schemeClr val="tx1"/>
+                          </a:solidFill>
+                        </a:rPr>
+                        <a:t>Net value</a:t>
+                      </a:r>
+                      <a:endParaRPr lang="en-US" sz="1250" dirty="0"/>
+                    </a:p>
+                  </a:txBody>
+                  <a:tcPr marL="101600" marR="101600" marT="50800" marB="50800" anchor="ctr">
+                    <a:lnL w="9525" cap="flat" cmpd="sng" algn="ctr">
+                      <a:solidFill>
+                        <a:srgbClr val="EAF2F2"/>
+                      </a:solidFill>
+                      <a:prstDash val="solid"/>
+                      <a:round/>
+                      <a:headEnd type="none" w="med" len="med"/>
+                      <a:tailEnd type="none" w="med" len="med"/>
+                    </a:lnL>
+                    <a:lnR w="9525" cap="flat" cmpd="sng" algn="ctr">
+                      <a:solidFill>
+                        <a:srgbClr val="EAF2F2"/>
+                      </a:solidFill>
+                      <a:prstDash val="solid"/>
+                      <a:round/>
+                      <a:headEnd type="none" w="med" len="med"/>
+                      <a:tailEnd type="none" w="med" len="med"/>
+                    </a:lnR>
+                    <a:lnT w="9525" cap="flat" cmpd="sng" algn="ctr">
+                      <a:solidFill>
+                        <a:srgbClr val="EAF2F2"/>
+                      </a:solidFill>
+                      <a:prstDash val="solid"/>
+                      <a:round/>
+                      <a:headEnd type="none" w="med" len="med"/>
+                      <a:tailEnd type="none" w="med" len="med"/>
+                    </a:lnT>
+                    <a:lnB w="9525" cap="flat" cmpd="sng" algn="ctr">
+                      <a:solidFill>
+                        <a:srgbClr val="EAF2F2"/>
+                      </a:solidFill>
+                      <a:prstDash val="solid"/>
+                      <a:round/>
+                      <a:headEnd type="none" w="med" len="med"/>
+                      <a:tailEnd type="none" w="med" len="med"/>
+                    </a:lnB>
+                    <a:solidFill>
+                      <a:schemeClr val="bg2"/>
+                    </a:solidFill>
+                  </a:tcPr>
+                </a:tc>
+                <a:tc>
+                  <a:txBody>
+                    <a:bodyPr/>
+                    <a:lstStyle/>
+                    <a:p>
+                      <a:pPr algn="ctr" indent="0" marL="0">
+                        <a:buNone/>
+                      </a:pPr>
+                      <a:r>
+                        <a:rPr lang="en-US" sz="1250" b="1" dirty="0">
+                          <a:solidFill>
+                            <a:schemeClr val="tx1"/>
+                          </a:solidFill>
+                        </a:rPr>
+                        <a:t>S$29.6k</a:t>
+                      </a:r>
+                      <a:endParaRPr lang="en-US" sz="1250" dirty="0"/>
+                    </a:p>
+                  </a:txBody>
+                  <a:tcPr marL="101600" marR="101600" marT="50800" marB="50800" anchor="ctr">
+                    <a:lnL w="9525" cap="flat" cmpd="sng" algn="ctr">
+                      <a:solidFill>
+                        <a:srgbClr val="EAF2F2"/>
+                      </a:solidFill>
+                      <a:prstDash val="solid"/>
+                      <a:round/>
+                      <a:headEnd type="none" w="med" len="med"/>
+                      <a:tailEnd type="none" w="med" len="med"/>
+                    </a:lnL>
+                    <a:lnR w="9525" cap="flat" cmpd="sng" algn="ctr">
+                      <a:solidFill>
+                        <a:srgbClr val="EAF2F2"/>
+                      </a:solidFill>
+                      <a:prstDash val="solid"/>
+                      <a:round/>
+                      <a:headEnd type="none" w="med" len="med"/>
+                      <a:tailEnd type="none" w="med" len="med"/>
+                    </a:lnR>
+                    <a:lnT w="9525" cap="flat" cmpd="sng" algn="ctr">
+                      <a:solidFill>
+                        <a:srgbClr val="EAF2F2"/>
+                      </a:solidFill>
+                      <a:prstDash val="solid"/>
+                      <a:round/>
+                      <a:headEnd type="none" w="med" len="med"/>
+                      <a:tailEnd type="none" w="med" len="med"/>
+                    </a:lnT>
+                    <a:lnB w="9525" cap="flat" cmpd="sng" algn="ctr">
+                      <a:solidFill>
+                        <a:srgbClr val="EAF2F2"/>
+                      </a:solidFill>
+                      <a:prstDash val="solid"/>
+                      <a:round/>
+                      <a:headEnd type="none" w="med" len="med"/>
+                      <a:tailEnd type="none" w="med" len="med"/>
+                    </a:lnB>
+                    <a:solidFill>
+                      <a:schemeClr val="bg2"/>
+                    </a:solidFill>
+                  </a:tcPr>
+                </a:tc>
+              </a:tr>
+            </a:tbl>
+          </a:graphicData>
+        </a:graphic>
+      </p:graphicFrame>
+      <p:sp>
+        <p:nvSpPr>
+          <p:cNvPr id="10" name="Assistant note"/>
+          <p:cNvSpPr txBox="1"/>
+          <p:nvPr/>
+        </p:nvSpPr>
+        <p:spPr>
+          <a:xfrm>
+            <a:off x="7452360" y="4892040"/>
+            <a:ext cx="4187952" cy="274320"/>
+          </a:xfrm>
+          <a:prstGeom prst="rect">
+            <a:avLst/>
+          </a:prstGeom>
+          <a:noFill/>
+          <a:ln/>
+        </p:spPr>
+        <p:txBody>
+          <a:bodyPr wrap="square" lIns="0" tIns="0" rIns="0" bIns="0" rtlCol="0" anchor="t"/>
+          <a:lstStyle/>
+          <a:p>
+            <a:pPr algn="l" indent="0" marL="0">
+              <a:buNone/>
+            </a:pPr>
+            <a:r>
+              <a:rPr lang="en-US" sz="1200" dirty="0">
+                <a:solidFill>
+                  <a:schemeClr val="accent2"/>
+                </a:solidFill>
+              </a:rPr>
+              <a:t>Hiring a full-time assistant instead: about S$49.1k a year.</a:t>
+            </a:r>
+            <a:endParaRPr lang="en-US" sz="1200" dirty="0"/>
+          </a:p>
+        </p:txBody>
+      </p:sp>
+      <p:sp>
+        <p:nvSpPr>
+          <p:cNvPr id="11" name="Banner"/>
+          <p:cNvSpPr/>
+          <p:nvPr/>
+        </p:nvSpPr>
+        <p:spPr>
+          <a:xfrm>
+            <a:off x="548640" y="5577840"/>
+            <a:ext cx="11091672" cy="566928"/>
+          </a:xfrm>
+          <a:prstGeom prst="roundRect">
+            <a:avLst>
+              <a:gd name="adj" fmla="val 12903"/>
+            </a:avLst>
+          </a:prstGeom>
+          <a:solidFill>
+            <a:schemeClr val="tx2"/>
+          </a:solidFill>
+          <a:ln/>
+        </p:spPr>
+      </p:sp>
+      <p:sp>
+        <p:nvSpPr>
+          <p:cNvPr id="12" name="Banner text"/>
+          <p:cNvSpPr txBox="1"/>
+          <p:nvPr/>
+        </p:nvSpPr>
+        <p:spPr>
+          <a:xfrm>
+            <a:off x="777240" y="5577840"/>
+            <a:ext cx="10698480" cy="566928"/>
+          </a:xfrm>
+          <a:prstGeom prst="rect">
+            <a:avLst/>
+          </a:prstGeom>
+          <a:noFill/>
+          <a:ln/>
+        </p:spPr>
+        <p:txBody>
+          <a:bodyPr wrap="square" lIns="0" tIns="0" rIns="0" bIns="0" rtlCol="0" anchor="ctr"/>
+          <a:lstStyle/>
+          <a:p>
+            <a:pPr algn="l" indent="0" marL="0">
+              <a:buNone/>
+            </a:pPr>
+            <a:r>
+              <a:rPr lang="en-US" sz="1400" b="1" dirty="0">
+                <a:solidFill>
+                  <a:schemeClr val="accent3"/>
+                </a:solidFill>
+              </a:rPr>
+              <a:t>Estimates, not measurements: </a:t>
+            </a:r>
+            <a:pPr algn="l" indent="0" marL="0">
+              <a:buNone/>
+            </a:pPr>
+            <a:r>
+              <a:rPr lang="en-US" sz="1400" dirty="0">
+                <a:solidFill>
+                  <a:schemeClr val="bg1"/>
+                </a:solidFill>
+              </a:rPr>
+              <a:t>no planner has been timed and prices are assumed (the data has none). Every input and its source: docs/business_case.md.</a:t>
+            </a:r>
+            <a:endParaRPr lang="en-US" sz="1400" dirty="0"/>
+          </a:p>
+        </p:txBody>
+      </p:sp>
+      <p:sp>
+        <p:nvSpPr>
+          <p:cNvPr id="25" name="Slide Number Placeholder 0"/>
+          <p:cNvSpPr>
+            <a:spLocks noGrp="1"/>
+          </p:cNvSpPr>
+          <p:nvPr>
+            <p:ph type="sldNum" sz="quarter" idx="4294967295"/>
+          </p:nvPr>
+        </p:nvSpPr>
+        <p:spPr>
+          <a:xfrm>
+            <a:off x="11137392" y="6382512"/>
+            <a:ext cx="502920" cy="274320"/>
+          </a:xfrm>
+          <a:prstGeom prst="rect">
+            <a:avLst/>
+          </a:prstGeom>
+          <a:extLst>
+            <a:ext uri="{C572A759-6A51-4108-AA02-DFA0A04FC94B}">
+              <ma14:wrappingTextBoxFlag xmlns:ma14="http://schemas.microsoft.com/office/mac/drawingml/2011/main" val="0"/>
+            </a:ext>
+          </a:extLst>
+        </p:spPr>
+        <p:txBody>
+          <a:bodyPr/>
+          <a:lstStyle>
+            <a:lvl1pPr>
+              <a:defRPr sz="1000">
+                <a:solidFill>
+                  <a:schemeClr val="accent5"/>
+                </a:solidFill>
+              </a:defRPr>
+            </a:lvl1pPr>
+          </a:lstStyle>
+          <a:p>
+            <a:pPr algn="r"/>
+            <a:fld id="{F7021451-1387-4CA6-816F-3879F97B5CBC}" type="slidenum">
+              <a:rPr b="0" lang="en-US"/>
+              <a:t>15</a:t>
+            </a:fld>
+            <a:endParaRPr lang="en-US"/>
+          </a:p>
+        </p:txBody>
+      </p:sp>
+    </p:spTree>
+  </p:cSld>
+  <p:clrMapOvr>
+    <a:masterClrMapping/>
+  </p:clrMapOvr>
+</p:sld>
+</file>
+
 <file path=ppt/slides/slide2.xml><?xml version="1.0" encoding="utf-8"?>
 <p:sld xmlns:a="http://schemas.openxmlformats.org/drawingml/2006/main" xmlns:r="http://schemas.openxmlformats.org/officeDocument/2006/relationships" xmlns:p="http://schemas.openxmlformats.org/presentationml/2006/main">
   <p:cSld name="Slide 2">
@@ -7359,14 +10500,53 @@
       </p:sp>
       <p:sp>
         <p:nvSpPr>
-          <p:cNvPr id="19" name="Note"/>
+          <p:cNvPr id="19" name="Stat net value"/>
           <p:cNvSpPr txBox="1"/>
           <p:nvPr/>
         </p:nvSpPr>
         <p:spPr>
           <a:xfrm>
-            <a:off x="8354568" y="2194560"/>
-            <a:ext cx="3057144" cy="914400"/>
+            <a:off x="8354568" y="2148840"/>
+            <a:ext cx="3057144" cy="731520"/>
+          </a:xfrm>
+          <a:prstGeom prst="rect">
+            <a:avLst/>
+          </a:prstGeom>
+          <a:noFill/>
+          <a:ln/>
+        </p:spPr>
+        <p:txBody>
+          <a:bodyPr wrap="square" lIns="0" tIns="0" rIns="0" bIns="0" rtlCol="0" anchor="ctr"/>
+          <a:lstStyle/>
+          <a:p>
+            <a:pPr algn="l" indent="0" marL="0">
+              <a:buNone/>
+            </a:pPr>
+            <a:r>
+              <a:rPr lang="en-US" sz="4400" b="1" dirty="0">
+                <a:solidFill>
+                  <a:schemeClr val="accent1"/>
+                </a:solidFill>
+                <a:latin typeface="Cambria" pitchFamily="34" charset="0"/>
+                <a:ea typeface="Cambria" pitchFamily="34" charset="-122"/>
+                <a:cs typeface="Cambria" pitchFamily="34" charset="-120"/>
+              </a:rPr>
+              <a:t>≈ S$29.6k</a:t>
+            </a:r>
+            <a:endParaRPr lang="en-US" sz="4400" dirty="0"/>
+          </a:p>
+        </p:txBody>
+      </p:sp>
+      <p:sp>
+        <p:nvSpPr>
+          <p:cNvPr id="20" name="Note"/>
+          <p:cNvSpPr txBox="1"/>
+          <p:nvPr/>
+        </p:nvSpPr>
+        <p:spPr>
+          <a:xfrm>
+            <a:off x="8354568" y="2862072"/>
+            <a:ext cx="3057144" cy="274320"/>
           </a:xfrm>
           <a:prstGeom prst="rect">
             <a:avLst/>
@@ -7382,66 +10562,27 @@
               <a:buNone/>
             </a:pPr>
             <a:r>
-              <a:rPr lang="en-US" sz="1300" dirty="0">
-                <a:solidFill>
-                  <a:schemeClr val="tx1"/>
-                </a:solidFill>
-              </a:rPr>
-              <a:t>In the brief's words: the planner's half hour every morning, plus every “let me check and call you back” during the day.</a:t>
-            </a:r>
-            <a:endParaRPr lang="en-US" sz="1300" dirty="0"/>
+              <a:rPr lang="en-US" sz="1200" dirty="0">
+                <a:solidFill>
+                  <a:schemeClr val="accent5"/>
+                </a:solidFill>
+              </a:rPr>
+              <a:t>net value a year, one factory (estimate)</a:t>
+            </a:r>
+            <a:endParaRPr lang="en-US" sz="1200" dirty="0"/>
           </a:p>
         </p:txBody>
       </p:sp>
       <p:sp>
         <p:nvSpPr>
-          <p:cNvPr id="20" name="Stat 5 of 5"/>
+          <p:cNvPr id="21" name="Value lines"/>
           <p:cNvSpPr txBox="1"/>
           <p:nvPr/>
         </p:nvSpPr>
         <p:spPr>
           <a:xfrm>
             <a:off x="8354568" y="3200400"/>
-            <a:ext cx="3057144" cy="868680"/>
-          </a:xfrm>
-          <a:prstGeom prst="rect">
-            <a:avLst/>
-          </a:prstGeom>
-          <a:noFill/>
-          <a:ln/>
-        </p:spPr>
-        <p:txBody>
-          <a:bodyPr wrap="square" lIns="0" tIns="0" rIns="0" bIns="0" rtlCol="0" anchor="ctr"/>
-          <a:lstStyle/>
-          <a:p>
-            <a:pPr algn="l" indent="0" marL="0">
-              <a:buNone/>
-            </a:pPr>
-            <a:r>
-              <a:rPr lang="en-US" sz="5400" b="1" dirty="0">
-                <a:solidFill>
-                  <a:schemeClr val="accent1"/>
-                </a:solidFill>
-                <a:latin typeface="Cambria" pitchFamily="34" charset="0"/>
-                <a:ea typeface="Cambria" pitchFamily="34" charset="-122"/>
-                <a:cs typeface="Cambria" pitchFamily="34" charset="-120"/>
-              </a:rPr>
-              <a:t>5 / 5</a:t>
-            </a:r>
-            <a:endParaRPr lang="en-US" sz="5400" dirty="0"/>
-          </a:p>
-        </p:txBody>
-      </p:sp>
-      <p:sp>
-        <p:nvSpPr>
-          <p:cNvPr id="21" name="Note"/>
-          <p:cNvSpPr txBox="1"/>
-          <p:nvPr/>
-        </p:nvSpPr>
-        <p:spPr>
-          <a:xfrm>
-            <a:off x="8354568" y="4069080"/>
-            <a:ext cx="3057144" cy="548640"/>
+            <a:ext cx="3057144" cy="1600200"/>
           </a:xfrm>
           <a:prstGeom prst="rect">
             <a:avLst/>
@@ -7454,34 +10595,113 @@
           <a:lstStyle/>
           <a:p>
             <a:pPr algn="l" indent="0" marL="0">
-              <a:buNone/>
-            </a:pPr>
-            <a:r>
-              <a:rPr lang="en-US" sz="1400" dirty="0">
+              <a:spcAft>
+                <a:spcPts val="600"/>
+              </a:spcAft>
+              <a:buNone/>
+            </a:pPr>
+            <a:r>
+              <a:rPr lang="en-US" sz="1200" b="1" dirty="0">
+                <a:solidFill>
+                  <a:schemeClr val="accent1"/>
+                </a:solidFill>
+              </a:rPr>
+              <a:t>+ S$18.4k  </a:t>
+            </a:r>
+            <a:pPr algn="l" indent="0" marL="0">
+              <a:spcAft>
+                <a:spcPts val="600"/>
+              </a:spcAft>
+              <a:buNone/>
+            </a:pPr>
+            <a:r>
+              <a:rPr lang="en-US" sz="1200" dirty="0">
                 <a:solidFill>
                   <a:schemeClr val="tx1"/>
                 </a:solidFill>
               </a:rPr>
-              <a:t>of the brief's daily questions are answered by a tool in our demo.</a:t>
-            </a:r>
-            <a:endParaRPr lang="en-US" sz="1400" dirty="0"/>
+              <a:t>62 planner hours a month freed: the morning report and call-backs (about a third of a person)</a:t>
+            </a:r>
+            <a:endParaRPr lang="en-US" sz="1200" dirty="0"/>
+          </a:p>
+          <a:p>
+            <a:pPr algn="l" indent="0" marL="0">
+              <a:spcAft>
+                <a:spcPts val="600"/>
+              </a:spcAft>
+              <a:buNone/>
+            </a:pPr>
+            <a:r>
+              <a:rPr lang="en-US" sz="1200" b="1" dirty="0">
+                <a:solidFill>
+                  <a:schemeClr val="accent1"/>
+                </a:solidFill>
+              </a:rPr>
+              <a:t>+ S$13.1k  </a:t>
+            </a:r>
+            <a:pPr algn="l" indent="0" marL="0">
+              <a:spcAft>
+                <a:spcPts val="600"/>
+              </a:spcAft>
+              <a:buNone/>
+            </a:pPr>
+            <a:r>
+              <a:rPr lang="en-US" sz="1200" dirty="0">
+                <a:solidFill>
+                  <a:schemeClr val="tx1"/>
+                </a:solidFill>
+              </a:rPr>
+              <a:t>late penalties avoided: about 30 fewer days of lateness every two months (simulated)</a:t>
+            </a:r>
+            <a:endParaRPr lang="en-US" sz="1200" dirty="0"/>
+          </a:p>
+          <a:p>
+            <a:pPr algn="l" indent="0" marL="0">
+              <a:spcAft>
+                <a:spcPts val="600"/>
+              </a:spcAft>
+              <a:buNone/>
+            </a:pPr>
+            <a:r>
+              <a:rPr lang="en-US" sz="1200" b="1" dirty="0">
+                <a:solidFill>
+                  <a:schemeClr val="accent2"/>
+                </a:solidFill>
+              </a:rPr>
+              <a:t>− S$1.9k  </a:t>
+            </a:r>
+            <a:pPr algn="l" indent="0" marL="0">
+              <a:spcAft>
+                <a:spcPts val="600"/>
+              </a:spcAft>
+              <a:buNone/>
+            </a:pPr>
+            <a:r>
+              <a:rPr lang="en-US" sz="1200" dirty="0">
+                <a:solidFill>
+                  <a:schemeClr val="tx1"/>
+                </a:solidFill>
+              </a:rPr>
+              <a:t>running it: OpenAI, CloudBase and upkeep</a:t>
+            </a:r>
+            <a:endParaRPr lang="en-US" sz="1200" dirty="0"/>
           </a:p>
         </p:txBody>
       </p:sp>
       <p:sp>
         <p:nvSpPr>
-          <p:cNvPr id="22" name="Not measured box"/>
+          <p:cNvPr id="22" name="Estimate box"/>
           <p:cNvSpPr/>
           <p:nvPr/>
         </p:nvSpPr>
         <p:spPr>
           <a:xfrm>
-            <a:off x="8354568" y="4617720"/>
-            <a:ext cx="3057144" cy="1325880"/>
+            <a:off x="8354568" y="4846320"/>
+            <a:ext cx="3057144" cy="1097280"/>
           </a:xfrm>
           <a:prstGeom prst="roundRect">
             <a:avLst>
-              <a:gd name="adj" fmla="val 5517"/>
+              <a:gd name="adj" fmla="val 6667"/>
             </a:avLst>
           </a:prstGeom>
           <a:solidFill>
@@ -7492,14 +10712,14 @@
       </p:sp>
       <p:sp>
         <p:nvSpPr>
-          <p:cNvPr id="23" name="Not measured text"/>
+          <p:cNvPr id="23" name="Estimate text"/>
           <p:cNvSpPr txBox="1"/>
           <p:nvPr/>
         </p:nvSpPr>
         <p:spPr>
           <a:xfrm>
-            <a:off x="8491728" y="4617720"/>
-            <a:ext cx="2782824" cy="1325880"/>
+            <a:off x="8491728" y="4846320"/>
+            <a:ext cx="2782824" cy="1097280"/>
           </a:xfrm>
           <a:prstGeom prst="rect">
             <a:avLst/>
@@ -7513,64 +10733,64 @@
           <a:p>
             <a:pPr algn="l" indent="0" marL="0">
               <a:spcAft>
-                <a:spcPts val="400"/>
+                <a:spcPts val="300"/>
               </a:spcAft>
               <a:buNone/>
             </a:pPr>
             <a:r>
-              <a:rPr lang="en-US" sz="1200" b="1" dirty="0">
+              <a:rPr lang="en-US" sz="1150" b="1" dirty="0">
                 <a:solidFill>
                   <a:schemeClr val="accent3"/>
                 </a:solidFill>
               </a:rPr>
-              <a:t>Not measured: </a:t>
+              <a:t>Instead of hiring: </a:t>
             </a:r>
             <a:pPr algn="l" indent="0" marL="0">
               <a:spcAft>
-                <a:spcPts val="400"/>
+                <a:spcPts val="300"/>
               </a:spcAft>
               <a:buNone/>
             </a:pPr>
             <a:r>
-              <a:rPr lang="en-US" sz="1200" dirty="0">
+              <a:rPr lang="en-US" sz="1150" dirty="0">
                 <a:solidFill>
                   <a:schemeClr val="bg1"/>
                 </a:solidFill>
               </a:rPr>
-              <a:t>time saved; no real manager has used it. </a:t>
-            </a:r>
-            <a:endParaRPr lang="en-US" sz="1200" dirty="0"/>
+              <a:t>a full-time assistant for on-call answers costs about S$49.1k a year. </a:t>
+            </a:r>
+            <a:endParaRPr lang="en-US" sz="1150" dirty="0"/>
           </a:p>
           <a:p>
             <a:pPr algn="l" indent="0" marL="0">
               <a:spcAft>
-                <a:spcPts val="400"/>
+                <a:spcPts val="300"/>
               </a:spcAft>
               <a:buNone/>
             </a:pPr>
             <a:r>
-              <a:rPr lang="en-US" sz="1200" b="1" dirty="0">
+              <a:rPr lang="en-US" sz="1150" b="1" dirty="0">
                 <a:solidFill>
                   <a:schemeClr val="accent3"/>
                 </a:solidFill>
               </a:rPr>
-              <a:t>In simulation: </a:t>
+              <a:t>Estimates: </a:t>
             </a:r>
             <a:pPr algn="l" indent="0" marL="0">
               <a:spcAft>
-                <a:spcPts val="400"/>
+                <a:spcPts val="300"/>
               </a:spcAft>
               <a:buNone/>
             </a:pPr>
             <a:r>
-              <a:rPr lang="en-US" sz="1200" dirty="0">
+              <a:rPr lang="en-US" sz="1150" dirty="0">
                 <a:solidFill>
                   <a:schemeClr val="bg1"/>
                 </a:solidFill>
               </a:rPr>
-              <a:t>finding problems through the briefing avoided about 30 working days of lateness per two months (95%: 18 to 43).</a:t>
-            </a:r>
-            <a:endParaRPr lang="en-US" sz="1200" dirty="0"/>
+              <a:t>task times and prices are assumptions; no planner timed yet (backup 15).</a:t>
+            </a:r>
+            <a:endParaRPr lang="en-US" sz="1150" dirty="0"/>
           </a:p>
         </p:txBody>
       </p:sp>

</xml_diff>